<commit_message>
deck: +多方討論 voices (8 roles) + 研討問題 discussion slides (26->38)
Folds the per-user feedback into the presentation: a 多方討論 section, one slide per
role (PM/老總/總承建商/判頭/工人/安全主任/業主/admin) carrying that persona's 心聲 +
👍最啱用 / 💢真實痛點被殺 / 🛠想改善 / ❓想問你 (an audience question per role), then a
研討問題 section with two open-question slides (功能向 = best/most-useful, pain killed,
what to cut; 落地向 = adoption friction, hardest role to onboard, pricing model,
deal-breakers).

- deck-content.json: +12 slides, inserted before the closing slide
- build-deck.mjs: new kinds voices/questions in HTML + jsPDF kicker chains; stops
  emitting presentation.pdf (jsPDF subset font can't embed emoji/full-CJK -> broken
  file that clobbered the good render)
- render-pdf.mjs (new): chromium print of presentation.html -> presentation.pdf,
  full CJK + emoji, 38 pages, 815KB
- regenerated html (42KB) / pdf (38pp) / pptx (199KB, 86-entry CRC-verified)

Co-Authored-By: Claude Opus 4.8 <noreply@anthropic.com>
</commit_message>
<xml_diff>
--- a/.planning/sim-2026/presentation.pptx
+++ b/.planning/sim-2026/presentation.pptx
@@ -31,6 +31,18 @@
     <p:sldId id="279" r:id="rId34"/>
     <p:sldId id="280" r:id="rId35"/>
     <p:sldId id="281" r:id="rId36"/>
+    <p:sldId id="282" r:id="rId37"/>
+    <p:sldId id="283" r:id="rId38"/>
+    <p:sldId id="284" r:id="rId39"/>
+    <p:sldId id="285" r:id="rId40"/>
+    <p:sldId id="286" r:id="rId41"/>
+    <p:sldId id="287" r:id="rId42"/>
+    <p:sldId id="288" r:id="rId43"/>
+    <p:sldId id="289" r:id="rId44"/>
+    <p:sldId id="290" r:id="rId45"/>
+    <p:sldId id="291" r:id="rId46"/>
+    <p:sldId id="292" r:id="rId47"/>
+    <p:sldId id="293" r:id="rId48"/>
   </p:sldIdLst>
   <p:sldSz cx="12192000" cy="6858000" type="screen16x9"/>
   <p:notesSz cx="6858000" cy="9144000"/>
@@ -4313,10 +4325,10 @@
             <a:r>
               <a:rPr lang="zh-HK" sz="3600" b="1">
                 <a:solidFill>
-                  <a:srgbClr val="F97316"/>
-                </a:solidFill>
-              </a:rPr>
-              <a:t>出 dispute 嗰陣,你唔需要靠記性</a:t>
+                  <a:srgbClr val="F8FAFC"/>
+                </a:solidFill>
+              </a:rPr>
+              <a:t>多方討論 —— 8 個角色點睇</a:t>
             </a:r>
           </a:p>
         </p:txBody>
@@ -4355,7 +4367,7 @@
                   <a:srgbClr val="F97316"/>
                 </a:solidFill>
               </a:rPr>
-              <a:t>一個系統,一條完整審計軌跡</a:t>
+              <a:t>唔係我哋講好，係每個崗位自己講</a:t>
             </a:r>
           </a:p>
           <a:p>
@@ -4375,49 +4387,21 @@
                   <a:srgbClr val="E2E8F0"/>
                 </a:solidFill>
               </a:rPr>
-              <a:t>判頭 + 工地主任永遠知道每個地盤發生緊乜事</a:t>
-            </a:r>
-          </a:p>
-          <a:p>
-            <a:pPr marL="285750" indent="-285750">
-              <a:buFont typeface="Arial"/>
-              <a:buChar char="•"/>
-            </a:pPr>
-            <a:r>
-              <a:rPr lang="zh-HK" sz="1400">
-                <a:solidFill>
-                  <a:srgbClr val="E2E8F0"/>
-                </a:solidFill>
-              </a:rPr>
-              <a:t>每一個指令、許可證、圖則、進度、問題都記低,改唔走、刪唔到</a:t>
-            </a:r>
-          </a:p>
-          <a:p>
-            <a:pPr marL="285750" indent="-285750">
-              <a:buFont typeface="Arial"/>
-              <a:buChar char="•"/>
-            </a:pPr>
-            <a:r>
-              <a:rPr lang="zh-HK" sz="1400">
-                <a:solidFill>
-                  <a:srgbClr val="E2E8F0"/>
-                </a:solidFill>
-              </a:rPr>
-              <a:t>iOS App Store 已上架 · Android 測試中 · 即開 Web 版</a:t>
-            </a:r>
-          </a:p>
-          <a:p>
-            <a:pPr marL="285750" indent="-285750">
-              <a:buFont typeface="Arial"/>
-              <a:buChar char="•"/>
-            </a:pPr>
-            <a:r>
-              <a:rPr lang="zh-HK" sz="1400">
-                <a:solidFill>
-                  <a:srgbClr val="E2E8F0"/>
-                </a:solidFill>
-              </a:rPr>
-              <a:t>想試?想 demo?想直接傾價? —— 揀一個,我哋當日搵你</a:t>
+              <a:t>由 4 類地盤模擬（大地盤 / 裝修 / 渠務 / 大樓維修）抽返每個角色嘅真實意見</a:t>
+            </a:r>
+          </a:p>
+          <a:p>
+            <a:pPr marL="285750" indent="-285750">
+              <a:buFont typeface="Arial"/>
+              <a:buChar char="•"/>
+            </a:pPr>
+            <a:r>
+              <a:rPr lang="zh-HK" sz="1400">
+                <a:solidFill>
+                  <a:srgbClr val="E2E8F0"/>
+                </a:solidFill>
+              </a:rPr>
+              <a:t>每張 slide：佢嘅心聲 + 👍最啱用 + 💢真實痛點被殺 + 🛠想改善 + ❓想問你</a:t>
             </a:r>
           </a:p>
           <a:p>
@@ -4436,7 +4420,661 @@
                   <a:srgbClr val="94A3B8"/>
                 </a:solidFill>
               </a:rPr>
-              <a:t>講者備註 · 收尾 CTA。回扣開場 thesis(永遠知道 + 審計軌跡)。三個渠道(App Store / Web / demo)。語氣輕鬆收結,留低聯絡。</a:t>
+              <a:t>講者備註 · 過場。同觀眾講：跟住落嚟唔係 sell 功能，係逐個崗位企出嚟講佢自己嘅嘢。可以叫返場入面對應崗位嘅人對號入座。</a:t>
+            </a:r>
+          </a:p>
+        </p:txBody>
+      </p:sp>
+    </p:spTree>
+  </p:cSld>
+  <p:clrMapOvr>
+    <a:overrideClrMapping bg1="dk1" tx1="lt1" bg2="dk2" tx2="lt2" accent1="accent1" accent2="accent2" accent3="accent3" accent4="accent4" accent5="accent5" accent6="accent6" hlink="hlink" folHlink="folHlink"/>
+  </p:clrMapOvr>
+</p:sld>
+</file>
+
+<file path=ppt/slides/slide27.xml><?xml version="1.0" encoding="utf-8"?>
+<p:sld xmlns:a="http://schemas.openxmlformats.org/drawingml/2006/main" xmlns:r="http://schemas.openxmlformats.org/officeDocument/2006/relationships" xmlns:p="http://schemas.openxmlformats.org/presentationml/2006/main">
+  <p:cSld>
+    <p:bg>
+      <p:bgPr>
+        <a:solidFill>
+          <a:srgbClr val="0F172A"/>
+        </a:solidFill>
+        <a:effectLst/>
+      </p:bgPr>
+    </p:bg>
+    <p:spTree>
+      <p:nvGrpSpPr>
+        <p:cNvPr id="1" name=""/>
+        <p:cNvGrpSpPr/>
+        <p:nvPr/>
+      </p:nvGrpSpPr>
+      <p:grpSpPr>
+        <a:xfrm>
+          <a:off x="0" y="0"/>
+          <a:ext cx="12192000" cy="6858000"/>
+          <a:chOff x="0" y="0"/>
+          <a:chExt cx="12192000" cy="6858000"/>
+        </a:xfrm>
+      </p:grpSpPr>
+      <p:sp>
+        <p:nvSpPr>
+          <p:cNvPr id="2" name="AccentBar"/>
+          <p:cNvSpPr/>
+          <p:nvPr/>
+        </p:nvSpPr>
+        <p:spPr>
+          <a:xfrm>
+            <a:off x="0" y="0"/>
+            <a:ext cx="114300" cy="6858000"/>
+          </a:xfrm>
+          <a:prstGeom prst="rect">
+            <a:avLst/>
+          </a:prstGeom>
+          <a:solidFill>
+            <a:srgbClr val="F97316"/>
+          </a:solidFill>
+        </p:spPr>
+        <p:txBody>
+          <a:bodyPr/>
+          <a:lstStyle/>
+          <a:p>
+            <a:endParaRPr lang="zh-HK"/>
+          </a:p>
+        </p:txBody>
+      </p:sp>
+      <p:sp>
+        <p:nvSpPr>
+          <p:cNvPr id="3" name="Title"/>
+          <p:cNvSpPr>
+            <a:spLocks noGrp="1"/>
+          </p:cNvSpPr>
+          <p:nvPr>
+            <p:ph type="title"/>
+          </p:nvPr>
+        </p:nvSpPr>
+        <p:spPr>
+          <a:xfrm>
+            <a:off x="457200" y="381000"/>
+            <a:ext cx="11277600" cy="1143000"/>
+          </a:xfrm>
+          <a:prstGeom prst="rect">
+            <a:avLst/>
+          </a:prstGeom>
+        </p:spPr>
+        <p:txBody>
+          <a:bodyPr anchor="t" wrap="square">
+            <a:normAutofit/>
+          </a:bodyPr>
+          <a:lstStyle/>
+          <a:p>
+            <a:pPr>
+              <a:buNone/>
+            </a:pPr>
+            <a:r>
+              <a:rPr lang="zh-HK" sz="2800" b="1">
+                <a:solidFill>
+                  <a:srgbClr val="F8FAFC"/>
+                </a:solidFill>
+              </a:rPr>
+              <a:t>項目經理 PM</a:t>
+            </a:r>
+          </a:p>
+        </p:txBody>
+      </p:sp>
+      <p:sp>
+        <p:nvSpPr>
+          <p:cNvPr id="4" name="Body"/>
+          <p:cNvSpPr>
+            <a:spLocks noGrp="1"/>
+          </p:cNvSpPr>
+          <p:nvPr>
+            <p:ph type="body" idx="1"/>
+          </p:nvPr>
+        </p:nvSpPr>
+        <p:spPr>
+          <a:xfrm>
+            <a:off x="457200" y="1619250"/>
+            <a:ext cx="11277600" cy="4857750"/>
+          </a:xfrm>
+          <a:prstGeom prst="rect">
+            <a:avLst/>
+          </a:prstGeom>
+        </p:spPr>
+        <p:txBody>
+          <a:bodyPr anchor="t" wrap="square">
+            <a:normAutofit/>
+          </a:bodyPr>
+          <a:lstStyle/>
+          <a:p>
+            <a:pPr>
+              <a:buNone/>
+            </a:pPr>
+            <a:r>
+              <a:rPr lang="zh-HK" sz="1600" b="1">
+                <a:solidFill>
+                  <a:srgbClr val="F97316"/>
+                </a:solidFill>
+              </a:rPr>
+              <a:t>我權限最大，跨 4 個地盤都睇到進度同問題</a:t>
+            </a:r>
+          </a:p>
+          <a:p>
+            <a:pPr>
+              <a:buNone/>
+            </a:pPr>
+            <a:endParaRPr lang="zh-HK" sz="600"/>
+          </a:p>
+          <a:p>
+            <a:pPr marL="285750" indent="-285750">
+              <a:buFont typeface="Arial"/>
+              <a:buChar char="•"/>
+            </a:pPr>
+            <a:r>
+              <a:rPr lang="zh-HK" sz="1400">
+                <a:solidFill>
+                  <a:srgbClr val="E2E8F0"/>
+                </a:solidFill>
+              </a:rPr>
+              <a:t>👍 最啱用：一鍵匯出 3 種報告（業主版 / 內部版 / 例外版），直接 WhatsApp send 老闆</a:t>
+            </a:r>
+          </a:p>
+          <a:p>
+            <a:pPr marL="285750" indent="-285750">
+              <a:buFont typeface="Arial"/>
+              <a:buChar char="•"/>
+            </a:pPr>
+            <a:r>
+              <a:rPr lang="zh-HK" sz="1400">
+                <a:solidFill>
+                  <a:srgbClr val="E2E8F0"/>
+                </a:solidFill>
+              </a:rPr>
+              <a:t>💢 痛點被殺：以前逐個地盤問判頭、翻 WhatsApp 先砌到份報告 —— 而家一㩒就有</a:t>
+            </a:r>
+          </a:p>
+          <a:p>
+            <a:pPr marL="285750" indent="-285750">
+              <a:buFont typeface="Arial"/>
+              <a:buChar char="•"/>
+            </a:pPr>
+            <a:r>
+              <a:rPr lang="zh-HK" sz="1400">
+                <a:solidFill>
+                  <a:srgbClr val="E2E8F0"/>
+                </a:solidFill>
+              </a:rPr>
+              <a:t>🛠 想改善：業主版要逐個項目整，想一次過跨項目出；有啲 flagship 文件簽核紀錄係空白</a:t>
+            </a:r>
+          </a:p>
+          <a:p>
+            <a:pPr marL="285750" indent="-285750">
+              <a:buFont typeface="Arial"/>
+              <a:buChar char="•"/>
+            </a:pPr>
+            <a:r>
+              <a:rPr lang="zh-HK" sz="1400">
+                <a:solidFill>
+                  <a:srgbClr val="E2E8F0"/>
+                </a:solidFill>
+              </a:rPr>
+              <a:t>❓ 想問你：你寧願每朝睇一個跨地盤總覽，定逐個地盤入去睇？</a:t>
+            </a:r>
+          </a:p>
+          <a:p>
+            <a:pPr>
+              <a:buNone/>
+            </a:pPr>
+            <a:endParaRPr lang="zh-HK" sz="600"/>
+          </a:p>
+          <a:p>
+            <a:pPr>
+              <a:buNone/>
+            </a:pPr>
+            <a:r>
+              <a:rPr lang="zh-HK" sz="1000" i="1">
+                <a:solidFill>
+                  <a:srgbClr val="94A3B8"/>
+                </a:solidFill>
+              </a:rPr>
+              <a:t>講者備註 · PM 係日常 power user。重點：報告匯出就係佢留低 app 嘅原因。問題拋出嚟，等做 PM 嗰位答。</a:t>
+            </a:r>
+          </a:p>
+        </p:txBody>
+      </p:sp>
+    </p:spTree>
+  </p:cSld>
+  <p:clrMapOvr>
+    <a:overrideClrMapping bg1="dk1" tx1="lt1" bg2="dk2" tx2="lt2" accent1="accent1" accent2="accent2" accent3="accent3" accent4="accent4" accent5="accent5" accent6="accent6" hlink="hlink" folHlink="folHlink"/>
+  </p:clrMapOvr>
+</p:sld>
+</file>
+
+<file path=ppt/slides/slide28.xml><?xml version="1.0" encoding="utf-8"?>
+<p:sld xmlns:a="http://schemas.openxmlformats.org/drawingml/2006/main" xmlns:r="http://schemas.openxmlformats.org/officeDocument/2006/relationships" xmlns:p="http://schemas.openxmlformats.org/presentationml/2006/main">
+  <p:cSld>
+    <p:bg>
+      <p:bgPr>
+        <a:solidFill>
+          <a:srgbClr val="0F172A"/>
+        </a:solidFill>
+        <a:effectLst/>
+      </p:bgPr>
+    </p:bg>
+    <p:spTree>
+      <p:nvGrpSpPr>
+        <p:cNvPr id="1" name=""/>
+        <p:cNvGrpSpPr/>
+        <p:nvPr/>
+      </p:nvGrpSpPr>
+      <p:grpSpPr>
+        <a:xfrm>
+          <a:off x="0" y="0"/>
+          <a:ext cx="12192000" cy="6858000"/>
+          <a:chOff x="0" y="0"/>
+          <a:chExt cx="12192000" cy="6858000"/>
+        </a:xfrm>
+      </p:grpSpPr>
+      <p:sp>
+        <p:nvSpPr>
+          <p:cNvPr id="2" name="AccentBar"/>
+          <p:cNvSpPr/>
+          <p:nvPr/>
+        </p:nvSpPr>
+        <p:spPr>
+          <a:xfrm>
+            <a:off x="0" y="0"/>
+            <a:ext cx="114300" cy="6858000"/>
+          </a:xfrm>
+          <a:prstGeom prst="rect">
+            <a:avLst/>
+          </a:prstGeom>
+          <a:solidFill>
+            <a:srgbClr val="F97316"/>
+          </a:solidFill>
+        </p:spPr>
+        <p:txBody>
+          <a:bodyPr/>
+          <a:lstStyle/>
+          <a:p>
+            <a:endParaRPr lang="zh-HK"/>
+          </a:p>
+        </p:txBody>
+      </p:sp>
+      <p:sp>
+        <p:nvSpPr>
+          <p:cNvPr id="3" name="Title"/>
+          <p:cNvSpPr>
+            <a:spLocks noGrp="1"/>
+          </p:cNvSpPr>
+          <p:nvPr>
+            <p:ph type="title"/>
+          </p:nvPr>
+        </p:nvSpPr>
+        <p:spPr>
+          <a:xfrm>
+            <a:off x="457200" y="381000"/>
+            <a:ext cx="11277600" cy="1143000"/>
+          </a:xfrm>
+          <a:prstGeom prst="rect">
+            <a:avLst/>
+          </a:prstGeom>
+        </p:spPr>
+        <p:txBody>
+          <a:bodyPr anchor="t" wrap="square">
+            <a:normAutofit/>
+          </a:bodyPr>
+          <a:lstStyle/>
+          <a:p>
+            <a:pPr>
+              <a:buNone/>
+            </a:pPr>
+            <a:r>
+              <a:rPr lang="zh-HK" sz="2800" b="1">
+                <a:solidFill>
+                  <a:srgbClr val="F8FAFC"/>
+                </a:solidFill>
+              </a:rPr>
+              <a:t>工地主任 老總（general_foreman）</a:t>
+            </a:r>
+          </a:p>
+        </p:txBody>
+      </p:sp>
+      <p:sp>
+        <p:nvSpPr>
+          <p:cNvPr id="4" name="Body"/>
+          <p:cNvSpPr>
+            <a:spLocks noGrp="1"/>
+          </p:cNvSpPr>
+          <p:nvPr>
+            <p:ph type="body" idx="1"/>
+          </p:nvPr>
+        </p:nvSpPr>
+        <p:spPr>
+          <a:xfrm>
+            <a:off x="457200" y="1619250"/>
+            <a:ext cx="11277600" cy="4857750"/>
+          </a:xfrm>
+          <a:prstGeom prst="rect">
+            <a:avLst/>
+          </a:prstGeom>
+        </p:spPr>
+        <p:txBody>
+          <a:bodyPr anchor="t" wrap="square">
+            <a:normAutofit/>
+          </a:bodyPr>
+          <a:lstStyle/>
+          <a:p>
+            <a:pPr>
+              <a:buNone/>
+            </a:pPr>
+            <a:r>
+              <a:rPr lang="zh-HK" sz="1600" b="1">
+                <a:solidFill>
+                  <a:srgbClr val="F97316"/>
+                </a:solidFill>
+              </a:rPr>
+              <a:t>我係地盤話事人，但起初好多模組當我透明</a:t>
+            </a:r>
+          </a:p>
+          <a:p>
+            <a:pPr>
+              <a:buNone/>
+            </a:pPr>
+            <a:endParaRPr lang="zh-HK" sz="600"/>
+          </a:p>
+          <a:p>
+            <a:pPr marL="285750" indent="-285750">
+              <a:buFont typeface="Arial"/>
+              <a:buChar char="•"/>
+            </a:pPr>
+            <a:r>
+              <a:rPr lang="zh-HK" sz="1400">
+                <a:solidFill>
+                  <a:srgbClr val="E2E8F0"/>
+                </a:solidFill>
+              </a:rPr>
+              <a:t>👍 最啱用：而家寫到施工日誌、郁到問題單、入到物料貨（權限已統一修好）</a:t>
+            </a:r>
+          </a:p>
+          <a:p>
+            <a:pPr marL="285750" indent="-285750">
+              <a:buFont typeface="Arial"/>
+              <a:buChar char="•"/>
+            </a:pPr>
+            <a:r>
+              <a:rPr lang="zh-HK" sz="1400">
+                <a:solidFill>
+                  <a:srgbClr val="E2E8F0"/>
+                </a:solidFill>
+              </a:rPr>
+              <a:t>💢 痛點被殺：以前要靠 PM 代我做、或者打電話落實 —— 而家自己一個 app 搞掂</a:t>
+            </a:r>
+          </a:p>
+          <a:p>
+            <a:pPr marL="285750" indent="-285750">
+              <a:buFont typeface="Arial"/>
+              <a:buChar char="•"/>
+            </a:pPr>
+            <a:r>
+              <a:rPr lang="zh-HK" sz="1400">
+                <a:solidFill>
+                  <a:srgbClr val="E2E8F0"/>
+                </a:solidFill>
+              </a:rPr>
+              <a:t>🛠 想改善：日誌 / 物料 / 問題每個模組權限規則唔同，記唔住邊個做到邊個</a:t>
+            </a:r>
+          </a:p>
+          <a:p>
+            <a:pPr marL="285750" indent="-285750">
+              <a:buFont typeface="Arial"/>
+              <a:buChar char="•"/>
+            </a:pPr>
+            <a:r>
+              <a:rPr lang="zh-HK" sz="1400">
+                <a:solidFill>
+                  <a:srgbClr val="E2E8F0"/>
+                </a:solidFill>
+              </a:rPr>
+              <a:t>❓ 想問你：工地主任應唔應該同 PM 一樣，咩都郁得到？</a:t>
+            </a:r>
+          </a:p>
+          <a:p>
+            <a:pPr>
+              <a:buNone/>
+            </a:pPr>
+            <a:endParaRPr lang="zh-HK" sz="600"/>
+          </a:p>
+          <a:p>
+            <a:pPr>
+              <a:buNone/>
+            </a:pPr>
+            <a:r>
+              <a:rPr lang="zh-HK" sz="1000" i="1">
+                <a:solidFill>
+                  <a:srgbClr val="94A3B8"/>
+                </a:solidFill>
+              </a:rPr>
+              <a:t>講者備註 · 老總係最容易被系統忽略嘅角色。承認返呢個係最大不滿、而家修好咗，可信度高。</a:t>
+            </a:r>
+          </a:p>
+        </p:txBody>
+      </p:sp>
+    </p:spTree>
+  </p:cSld>
+  <p:clrMapOvr>
+    <a:overrideClrMapping bg1="dk1" tx1="lt1" bg2="dk2" tx2="lt2" accent1="accent1" accent2="accent2" accent3="accent3" accent4="accent4" accent5="accent5" accent6="accent6" hlink="hlink" folHlink="folHlink"/>
+  </p:clrMapOvr>
+</p:sld>
+</file>
+
+<file path=ppt/slides/slide29.xml><?xml version="1.0" encoding="utf-8"?>
+<p:sld xmlns:a="http://schemas.openxmlformats.org/drawingml/2006/main" xmlns:r="http://schemas.openxmlformats.org/officeDocument/2006/relationships" xmlns:p="http://schemas.openxmlformats.org/presentationml/2006/main">
+  <p:cSld>
+    <p:bg>
+      <p:bgPr>
+        <a:solidFill>
+          <a:srgbClr val="0F172A"/>
+        </a:solidFill>
+        <a:effectLst/>
+      </p:bgPr>
+    </p:bg>
+    <p:spTree>
+      <p:nvGrpSpPr>
+        <p:cNvPr id="1" name=""/>
+        <p:cNvGrpSpPr/>
+        <p:nvPr/>
+      </p:nvGrpSpPr>
+      <p:grpSpPr>
+        <a:xfrm>
+          <a:off x="0" y="0"/>
+          <a:ext cx="12192000" cy="6858000"/>
+          <a:chOff x="0" y="0"/>
+          <a:chExt cx="12192000" cy="6858000"/>
+        </a:xfrm>
+      </p:grpSpPr>
+      <p:sp>
+        <p:nvSpPr>
+          <p:cNvPr id="2" name="AccentBar"/>
+          <p:cNvSpPr/>
+          <p:nvPr/>
+        </p:nvSpPr>
+        <p:spPr>
+          <a:xfrm>
+            <a:off x="0" y="0"/>
+            <a:ext cx="114300" cy="6858000"/>
+          </a:xfrm>
+          <a:prstGeom prst="rect">
+            <a:avLst/>
+          </a:prstGeom>
+          <a:solidFill>
+            <a:srgbClr val="F97316"/>
+          </a:solidFill>
+        </p:spPr>
+        <p:txBody>
+          <a:bodyPr/>
+          <a:lstStyle/>
+          <a:p>
+            <a:endParaRPr lang="zh-HK"/>
+          </a:p>
+        </p:txBody>
+      </p:sp>
+      <p:sp>
+        <p:nvSpPr>
+          <p:cNvPr id="3" name="Title"/>
+          <p:cNvSpPr>
+            <a:spLocks noGrp="1"/>
+          </p:cNvSpPr>
+          <p:nvPr>
+            <p:ph type="title"/>
+          </p:nvPr>
+        </p:nvSpPr>
+        <p:spPr>
+          <a:xfrm>
+            <a:off x="457200" y="381000"/>
+            <a:ext cx="11277600" cy="1143000"/>
+          </a:xfrm>
+          <a:prstGeom prst="rect">
+            <a:avLst/>
+          </a:prstGeom>
+        </p:spPr>
+        <p:txBody>
+          <a:bodyPr anchor="t" wrap="square">
+            <a:normAutofit/>
+          </a:bodyPr>
+          <a:lstStyle/>
+          <a:p>
+            <a:pPr>
+              <a:buNone/>
+            </a:pPr>
+            <a:r>
+              <a:rPr lang="zh-HK" sz="2800" b="1">
+                <a:solidFill>
+                  <a:srgbClr val="F8FAFC"/>
+                </a:solidFill>
+              </a:rPr>
+              <a:t>總承建商 main_contractor</a:t>
+            </a:r>
+          </a:p>
+        </p:txBody>
+      </p:sp>
+      <p:sp>
+        <p:nvSpPr>
+          <p:cNvPr id="4" name="Body"/>
+          <p:cNvSpPr>
+            <a:spLocks noGrp="1"/>
+          </p:cNvSpPr>
+          <p:nvPr>
+            <p:ph type="body" idx="1"/>
+          </p:nvPr>
+        </p:nvSpPr>
+        <p:spPr>
+          <a:xfrm>
+            <a:off x="457200" y="1619250"/>
+            <a:ext cx="11277600" cy="4857750"/>
+          </a:xfrm>
+          <a:prstGeom prst="rect">
+            <a:avLst/>
+          </a:prstGeom>
+        </p:spPr>
+        <p:txBody>
+          <a:bodyPr anchor="t" wrap="square">
+            <a:normAutofit/>
+          </a:bodyPr>
+          <a:lstStyle/>
+          <a:p>
+            <a:pPr>
+              <a:buNone/>
+            </a:pPr>
+            <a:r>
+              <a:rPr lang="zh-HK" sz="1600" b="1">
+                <a:solidFill>
+                  <a:srgbClr val="F97316"/>
+                </a:solidFill>
+              </a:rPr>
+              <a:t>SI→VO 設計變更流程同金額自動計，做得好</a:t>
+            </a:r>
+          </a:p>
+          <a:p>
+            <a:pPr>
+              <a:buNone/>
+            </a:pPr>
+            <a:endParaRPr lang="zh-HK" sz="600"/>
+          </a:p>
+          <a:p>
+            <a:pPr marL="285750" indent="-285750">
+              <a:buFont typeface="Arial"/>
+              <a:buChar char="•"/>
+            </a:pPr>
+            <a:r>
+              <a:rPr lang="zh-HK" sz="1400">
+                <a:solidFill>
+                  <a:srgbClr val="E2E8F0"/>
+                </a:solidFill>
+              </a:rPr>
+              <a:t>👍 最啱用：工地指令 SI → 變更單 VO 一條鏈，金額自動計、自動連埋</a:t>
+            </a:r>
+          </a:p>
+          <a:p>
+            <a:pPr marL="285750" indent="-285750">
+              <a:buFont typeface="Arial"/>
+              <a:buChar char="•"/>
+            </a:pPr>
+            <a:r>
+              <a:rPr lang="zh-HK" sz="1400">
+                <a:solidFill>
+                  <a:srgbClr val="E2E8F0"/>
+                </a:solidFill>
+              </a:rPr>
+              <a:t>💢 痛點被殺：以前變更靠口頭 / 紙仔，爭錢嗰陣冇證據 —— 而家成條鏈記晒邊個批、幾時批</a:t>
+            </a:r>
+          </a:p>
+          <a:p>
+            <a:pPr marL="285750" indent="-285750">
+              <a:buFont typeface="Arial"/>
+              <a:buChar char="•"/>
+            </a:pPr>
+            <a:r>
+              <a:rPr lang="zh-HK" sz="1400">
+                <a:solidFill>
+                  <a:srgbClr val="E2E8F0"/>
+                </a:solidFill>
+              </a:rPr>
+              <a:t>🛠 想改善：見到「加物料」掣但入唔到貨（編輯權限同建立權限對唔上，已修）</a:t>
+            </a:r>
+          </a:p>
+          <a:p>
+            <a:pPr marL="285750" indent="-285750">
+              <a:buFont typeface="Arial"/>
+              <a:buChar char="•"/>
+            </a:pPr>
+            <a:r>
+              <a:rPr lang="zh-HK" sz="1400">
+                <a:solidFill>
+                  <a:srgbClr val="E2E8F0"/>
+                </a:solidFill>
+              </a:rPr>
+              <a:t>❓ 想問你：你個 VO 流程，最想系統幫你卡死邊一步？</a:t>
+            </a:r>
+          </a:p>
+          <a:p>
+            <a:pPr>
+              <a:buNone/>
+            </a:pPr>
+            <a:endParaRPr lang="zh-HK" sz="600"/>
+          </a:p>
+          <a:p>
+            <a:pPr>
+              <a:buNone/>
+            </a:pPr>
+            <a:r>
+              <a:rPr lang="zh-HK" sz="1000" i="1">
+                <a:solidFill>
+                  <a:srgbClr val="94A3B8"/>
+                </a:solidFill>
+              </a:rPr>
+              <a:t>講者備註 · MC 最在意錢同證據鏈。VO→錢 嘅自動計係硬賣點。</a:t>
             </a:r>
           </a:p>
         </p:txBody>
@@ -4669,6 +5307,1968 @@
                 </a:solidFill>
               </a:rPr>
               <a:t>講者備註 · 三宗罪逐個講。重點唔係話佢哋蠢，而係呢啲工具本身唔係為地盤協作而設。每一條痛點都對應後面一個功能 —— 此刻只負責令佢哋點頭。</a:t>
+            </a:r>
+          </a:p>
+        </p:txBody>
+      </p:sp>
+    </p:spTree>
+  </p:cSld>
+  <p:clrMapOvr>
+    <a:overrideClrMapping bg1="dk1" tx1="lt1" bg2="dk2" tx2="lt2" accent1="accent1" accent2="accent2" accent3="accent3" accent4="accent4" accent5="accent5" accent6="accent6" hlink="hlink" folHlink="folHlink"/>
+  </p:clrMapOvr>
+</p:sld>
+</file>
+
+<file path=ppt/slides/slide30.xml><?xml version="1.0" encoding="utf-8"?>
+<p:sld xmlns:a="http://schemas.openxmlformats.org/drawingml/2006/main" xmlns:r="http://schemas.openxmlformats.org/officeDocument/2006/relationships" xmlns:p="http://schemas.openxmlformats.org/presentationml/2006/main">
+  <p:cSld>
+    <p:bg>
+      <p:bgPr>
+        <a:solidFill>
+          <a:srgbClr val="0F172A"/>
+        </a:solidFill>
+        <a:effectLst/>
+      </p:bgPr>
+    </p:bg>
+    <p:spTree>
+      <p:nvGrpSpPr>
+        <p:cNvPr id="1" name=""/>
+        <p:cNvGrpSpPr/>
+        <p:nvPr/>
+      </p:nvGrpSpPr>
+      <p:grpSpPr>
+        <a:xfrm>
+          <a:off x="0" y="0"/>
+          <a:ext cx="12192000" cy="6858000"/>
+          <a:chOff x="0" y="0"/>
+          <a:chExt cx="12192000" cy="6858000"/>
+        </a:xfrm>
+      </p:grpSpPr>
+      <p:sp>
+        <p:nvSpPr>
+          <p:cNvPr id="2" name="AccentBar"/>
+          <p:cNvSpPr/>
+          <p:nvPr/>
+        </p:nvSpPr>
+        <p:spPr>
+          <a:xfrm>
+            <a:off x="0" y="0"/>
+            <a:ext cx="114300" cy="6858000"/>
+          </a:xfrm>
+          <a:prstGeom prst="rect">
+            <a:avLst/>
+          </a:prstGeom>
+          <a:solidFill>
+            <a:srgbClr val="F97316"/>
+          </a:solidFill>
+        </p:spPr>
+        <p:txBody>
+          <a:bodyPr/>
+          <a:lstStyle/>
+          <a:p>
+            <a:endParaRPr lang="zh-HK"/>
+          </a:p>
+        </p:txBody>
+      </p:sp>
+      <p:sp>
+        <p:nvSpPr>
+          <p:cNvPr id="3" name="Title"/>
+          <p:cNvSpPr>
+            <a:spLocks noGrp="1"/>
+          </p:cNvSpPr>
+          <p:nvPr>
+            <p:ph type="title"/>
+          </p:nvPr>
+        </p:nvSpPr>
+        <p:spPr>
+          <a:xfrm>
+            <a:off x="457200" y="381000"/>
+            <a:ext cx="11277600" cy="1143000"/>
+          </a:xfrm>
+          <a:prstGeom prst="rect">
+            <a:avLst/>
+          </a:prstGeom>
+        </p:spPr>
+        <p:txBody>
+          <a:bodyPr anchor="t" wrap="square">
+            <a:normAutofit/>
+          </a:bodyPr>
+          <a:lstStyle/>
+          <a:p>
+            <a:pPr>
+              <a:buNone/>
+            </a:pPr>
+            <a:r>
+              <a:rPr lang="zh-HK" sz="2800" b="1">
+                <a:solidFill>
+                  <a:srgbClr val="F8FAFC"/>
+                </a:solidFill>
+              </a:rPr>
+              <a:t>判頭 subcontractor</a:t>
+            </a:r>
+          </a:p>
+        </p:txBody>
+      </p:sp>
+      <p:sp>
+        <p:nvSpPr>
+          <p:cNvPr id="4" name="Body"/>
+          <p:cNvSpPr>
+            <a:spLocks noGrp="1"/>
+          </p:cNvSpPr>
+          <p:nvPr>
+            <p:ph type="body" idx="1"/>
+          </p:nvPr>
+        </p:nvSpPr>
+        <p:spPr>
+          <a:xfrm>
+            <a:off x="457200" y="1619250"/>
+            <a:ext cx="11277600" cy="4857750"/>
+          </a:xfrm>
+          <a:prstGeom prst="rect">
+            <a:avLst/>
+          </a:prstGeom>
+        </p:spPr>
+        <p:txBody>
+          <a:bodyPr anchor="t" wrap="square">
+            <a:normAutofit/>
+          </a:bodyPr>
+          <a:lstStyle/>
+          <a:p>
+            <a:pPr>
+              <a:buNone/>
+            </a:pPr>
+            <a:r>
+              <a:rPr lang="zh-HK" sz="1600" b="1">
+                <a:solidFill>
+                  <a:srgbClr val="F97316"/>
+                </a:solidFill>
+              </a:rPr>
+              <a:t>派俾我嘅工序做到、更新到；睇唔到全貌係正常設計</a:t>
+            </a:r>
+          </a:p>
+          <a:p>
+            <a:pPr>
+              <a:buNone/>
+            </a:pPr>
+            <a:endParaRPr lang="zh-HK" sz="600"/>
+          </a:p>
+          <a:p>
+            <a:pPr marL="285750" indent="-285750">
+              <a:buFont typeface="Arial"/>
+              <a:buChar char="•"/>
+            </a:pPr>
+            <a:r>
+              <a:rPr lang="zh-HK" sz="1400">
+                <a:solidFill>
+                  <a:srgbClr val="E2E8F0"/>
+                </a:solidFill>
+              </a:rPr>
+              <a:t>👍 最啱用：物料逾期清單一目了然 + 派俾我嘅工序更新得快</a:t>
+            </a:r>
+          </a:p>
+          <a:p>
+            <a:pPr marL="285750" indent="-285750">
+              <a:buFont typeface="Arial"/>
+              <a:buChar char="•"/>
+            </a:pPr>
+            <a:r>
+              <a:rPr lang="zh-HK" sz="1400">
+                <a:solidFill>
+                  <a:srgbClr val="E2E8F0"/>
+                </a:solidFill>
+              </a:rPr>
+              <a:t>💢 痛點被殺：以前唔知邊批料遲到、邊樣等緊 —— 而家逾期清單自己彈出嚟</a:t>
+            </a:r>
+          </a:p>
+          <a:p>
+            <a:pPr marL="285750" indent="-285750">
+              <a:buFont typeface="Arial"/>
+              <a:buChar char="•"/>
+            </a:pPr>
+            <a:r>
+              <a:rPr lang="zh-HK" sz="1400">
+                <a:solidFill>
+                  <a:srgbClr val="E2E8F0"/>
+                </a:solidFill>
+              </a:rPr>
+              <a:t>🛠 想改善：有啲明明係我落手做嘅工序，系統話我冇權記錄歷史</a:t>
+            </a:r>
+          </a:p>
+          <a:p>
+            <a:pPr marL="285750" indent="-285750">
+              <a:buFont typeface="Arial"/>
+              <a:buChar char="•"/>
+            </a:pPr>
+            <a:r>
+              <a:rPr lang="zh-HK" sz="1400">
+                <a:solidFill>
+                  <a:srgbClr val="E2E8F0"/>
+                </a:solidFill>
+              </a:rPr>
+              <a:t>❓ 想問你：判頭應唔應該睇到全地盤進度，定淨係自己嗰 part？</a:t>
+            </a:r>
+          </a:p>
+          <a:p>
+            <a:pPr>
+              <a:buNone/>
+            </a:pPr>
+            <a:endParaRPr lang="zh-HK" sz="600"/>
+          </a:p>
+          <a:p>
+            <a:pPr>
+              <a:buNone/>
+            </a:pPr>
+            <a:r>
+              <a:rPr lang="zh-HK" sz="1000" i="1">
+                <a:solidFill>
+                  <a:srgbClr val="94A3B8"/>
+                </a:solidFill>
+              </a:rPr>
+              <a:t>講者備註 · 判頭關心：派俾我嘅嘢 + 等緊乜料。territory 範圍係刻意收窄，要解釋清楚。</a:t>
+            </a:r>
+          </a:p>
+        </p:txBody>
+      </p:sp>
+    </p:spTree>
+  </p:cSld>
+  <p:clrMapOvr>
+    <a:overrideClrMapping bg1="dk1" tx1="lt1" bg2="dk2" tx2="lt2" accent1="accent1" accent2="accent2" accent3="accent3" accent4="accent4" accent5="accent5" accent6="accent6" hlink="hlink" folHlink="folHlink"/>
+  </p:clrMapOvr>
+</p:sld>
+</file>
+
+<file path=ppt/slides/slide31.xml><?xml version="1.0" encoding="utf-8"?>
+<p:sld xmlns:a="http://schemas.openxmlformats.org/drawingml/2006/main" xmlns:r="http://schemas.openxmlformats.org/officeDocument/2006/relationships" xmlns:p="http://schemas.openxmlformats.org/presentationml/2006/main">
+  <p:cSld>
+    <p:bg>
+      <p:bgPr>
+        <a:solidFill>
+          <a:srgbClr val="0F172A"/>
+        </a:solidFill>
+        <a:effectLst/>
+      </p:bgPr>
+    </p:bg>
+    <p:spTree>
+      <p:nvGrpSpPr>
+        <p:cNvPr id="1" name=""/>
+        <p:cNvGrpSpPr/>
+        <p:nvPr/>
+      </p:nvGrpSpPr>
+      <p:grpSpPr>
+        <a:xfrm>
+          <a:off x="0" y="0"/>
+          <a:ext cx="12192000" cy="6858000"/>
+          <a:chOff x="0" y="0"/>
+          <a:chExt cx="12192000" cy="6858000"/>
+        </a:xfrm>
+      </p:grpSpPr>
+      <p:sp>
+        <p:nvSpPr>
+          <p:cNvPr id="2" name="AccentBar"/>
+          <p:cNvSpPr/>
+          <p:nvPr/>
+        </p:nvSpPr>
+        <p:spPr>
+          <a:xfrm>
+            <a:off x="0" y="0"/>
+            <a:ext cx="114300" cy="6858000"/>
+          </a:xfrm>
+          <a:prstGeom prst="rect">
+            <a:avLst/>
+          </a:prstGeom>
+          <a:solidFill>
+            <a:srgbClr val="F97316"/>
+          </a:solidFill>
+        </p:spPr>
+        <p:txBody>
+          <a:bodyPr/>
+          <a:lstStyle/>
+          <a:p>
+            <a:endParaRPr lang="zh-HK"/>
+          </a:p>
+        </p:txBody>
+      </p:sp>
+      <p:sp>
+        <p:nvSpPr>
+          <p:cNvPr id="3" name="Title"/>
+          <p:cNvSpPr>
+            <a:spLocks noGrp="1"/>
+          </p:cNvSpPr>
+          <p:nvPr>
+            <p:ph type="title"/>
+          </p:nvPr>
+        </p:nvSpPr>
+        <p:spPr>
+          <a:xfrm>
+            <a:off x="457200" y="381000"/>
+            <a:ext cx="11277600" cy="1143000"/>
+          </a:xfrm>
+          <a:prstGeom prst="rect">
+            <a:avLst/>
+          </a:prstGeom>
+        </p:spPr>
+        <p:txBody>
+          <a:bodyPr anchor="t" wrap="square">
+            <a:normAutofit/>
+          </a:bodyPr>
+          <a:lstStyle/>
+          <a:p>
+            <a:pPr>
+              <a:buNone/>
+            </a:pPr>
+            <a:r>
+              <a:rPr lang="zh-HK" sz="2800" b="1">
+                <a:solidFill>
+                  <a:srgbClr val="F8FAFC"/>
+                </a:solidFill>
+              </a:rPr>
+              <a:t>判頭工人 worker</a:t>
+            </a:r>
+          </a:p>
+        </p:txBody>
+      </p:sp>
+      <p:sp>
+        <p:nvSpPr>
+          <p:cNvPr id="4" name="Body"/>
+          <p:cNvSpPr>
+            <a:spLocks noGrp="1"/>
+          </p:cNvSpPr>
+          <p:nvPr>
+            <p:ph type="body" idx="1"/>
+          </p:nvPr>
+        </p:nvSpPr>
+        <p:spPr>
+          <a:xfrm>
+            <a:off x="457200" y="1619250"/>
+            <a:ext cx="11277600" cy="4857750"/>
+          </a:xfrm>
+          <a:prstGeom prst="rect">
+            <a:avLst/>
+          </a:prstGeom>
+        </p:spPr>
+        <p:txBody>
+          <a:bodyPr anchor="t" wrap="square">
+            <a:normAutofit/>
+          </a:bodyPr>
+          <a:lstStyle/>
+          <a:p>
+            <a:pPr>
+              <a:buNone/>
+            </a:pPr>
+            <a:r>
+              <a:rPr lang="zh-HK" sz="1600" b="1">
+                <a:solidFill>
+                  <a:srgbClr val="F97316"/>
+                </a:solidFill>
+              </a:rPr>
+              <a:t>淨係見到派俾我嗰幾條細項，影相報問題好直接</a:t>
+            </a:r>
+          </a:p>
+          <a:p>
+            <a:pPr>
+              <a:buNone/>
+            </a:pPr>
+            <a:endParaRPr lang="zh-HK" sz="600"/>
+          </a:p>
+          <a:p>
+            <a:pPr marL="285750" indent="-285750">
+              <a:buFont typeface="Arial"/>
+              <a:buChar char="•"/>
+            </a:pPr>
+            <a:r>
+              <a:rPr lang="zh-HK" sz="1400">
+                <a:solidFill>
+                  <a:srgbClr val="E2E8F0"/>
+                </a:solidFill>
+              </a:rPr>
+              <a:t>👍 最啱用：影相 → 報問題，一兩 tap 搞掂</a:t>
+            </a:r>
+          </a:p>
+          <a:p>
+            <a:pPr marL="285750" indent="-285750">
+              <a:buFont typeface="Arial"/>
+              <a:buChar char="•"/>
+            </a:pPr>
+            <a:r>
+              <a:rPr lang="zh-HK" sz="1400">
+                <a:solidFill>
+                  <a:srgbClr val="E2E8F0"/>
+                </a:solidFill>
+              </a:rPr>
+              <a:t>💢 痛點被殺：以前出事影完相 send 落 WhatsApp group 冇人理、又搵唔返 —— 而家入單有人跟、有紀錄</a:t>
+            </a:r>
+          </a:p>
+          <a:p>
+            <a:pPr marL="285750" indent="-285750">
+              <a:buFont typeface="Arial"/>
+              <a:buChar char="•"/>
+            </a:pPr>
+            <a:r>
+              <a:rPr lang="zh-HK" sz="1400">
+                <a:solidFill>
+                  <a:srgbClr val="E2E8F0"/>
+                </a:solidFill>
+              </a:rPr>
+              <a:t>🛠 想改善：一開始根本冇人派嘢俾我，入到去白茫茫一片乜都做唔到（已派工序）</a:t>
+            </a:r>
+          </a:p>
+          <a:p>
+            <a:pPr marL="285750" indent="-285750">
+              <a:buFont typeface="Arial"/>
+              <a:buChar char="•"/>
+            </a:pPr>
+            <a:r>
+              <a:rPr lang="zh-HK" sz="1400">
+                <a:solidFill>
+                  <a:srgbClr val="E2E8F0"/>
+                </a:solidFill>
+              </a:rPr>
+              <a:t>❓ 想問你：工人界面係咪應該預設淨係得「我嘅嘢 + 影相報問題」兩個掣？</a:t>
+            </a:r>
+          </a:p>
+          <a:p>
+            <a:pPr>
+              <a:buNone/>
+            </a:pPr>
+            <a:endParaRPr lang="zh-HK" sz="600"/>
+          </a:p>
+          <a:p>
+            <a:pPr>
+              <a:buNone/>
+            </a:pPr>
+            <a:r>
+              <a:rPr lang="zh-HK" sz="1000" i="1">
+                <a:solidFill>
+                  <a:srgbClr val="94A3B8"/>
+                </a:solidFill>
+              </a:rPr>
+              <a:t>講者備註 · 工人 = 最唔 tech 嘅 user，介面要蠢到唔使學。影相報問題係佢唯一日日用嘅嘢。</a:t>
+            </a:r>
+          </a:p>
+        </p:txBody>
+      </p:sp>
+    </p:spTree>
+  </p:cSld>
+  <p:clrMapOvr>
+    <a:overrideClrMapping bg1="dk1" tx1="lt1" bg2="dk2" tx2="lt2" accent1="accent1" accent2="accent2" accent3="accent3" accent4="accent4" accent5="accent5" accent6="accent6" hlink="hlink" folHlink="folHlink"/>
+  </p:clrMapOvr>
+</p:sld>
+</file>
+
+<file path=ppt/slides/slide32.xml><?xml version="1.0" encoding="utf-8"?>
+<p:sld xmlns:a="http://schemas.openxmlformats.org/drawingml/2006/main" xmlns:r="http://schemas.openxmlformats.org/officeDocument/2006/relationships" xmlns:p="http://schemas.openxmlformats.org/presentationml/2006/main">
+  <p:cSld>
+    <p:bg>
+      <p:bgPr>
+        <a:solidFill>
+          <a:srgbClr val="0F172A"/>
+        </a:solidFill>
+        <a:effectLst/>
+      </p:bgPr>
+    </p:bg>
+    <p:spTree>
+      <p:nvGrpSpPr>
+        <p:cNvPr id="1" name=""/>
+        <p:cNvGrpSpPr/>
+        <p:nvPr/>
+      </p:nvGrpSpPr>
+      <p:grpSpPr>
+        <a:xfrm>
+          <a:off x="0" y="0"/>
+          <a:ext cx="12192000" cy="6858000"/>
+          <a:chOff x="0" y="0"/>
+          <a:chExt cx="12192000" cy="6858000"/>
+        </a:xfrm>
+      </p:grpSpPr>
+      <p:sp>
+        <p:nvSpPr>
+          <p:cNvPr id="2" name="AccentBar"/>
+          <p:cNvSpPr/>
+          <p:nvPr/>
+        </p:nvSpPr>
+        <p:spPr>
+          <a:xfrm>
+            <a:off x="0" y="0"/>
+            <a:ext cx="114300" cy="6858000"/>
+          </a:xfrm>
+          <a:prstGeom prst="rect">
+            <a:avLst/>
+          </a:prstGeom>
+          <a:solidFill>
+            <a:srgbClr val="F97316"/>
+          </a:solidFill>
+        </p:spPr>
+        <p:txBody>
+          <a:bodyPr/>
+          <a:lstStyle/>
+          <a:p>
+            <a:endParaRPr lang="zh-HK"/>
+          </a:p>
+        </p:txBody>
+      </p:sp>
+      <p:sp>
+        <p:nvSpPr>
+          <p:cNvPr id="3" name="Title"/>
+          <p:cNvSpPr>
+            <a:spLocks noGrp="1"/>
+          </p:cNvSpPr>
+          <p:nvPr>
+            <p:ph type="title"/>
+          </p:nvPr>
+        </p:nvSpPr>
+        <p:spPr>
+          <a:xfrm>
+            <a:off x="457200" y="381000"/>
+            <a:ext cx="11277600" cy="1143000"/>
+          </a:xfrm>
+          <a:prstGeom prst="rect">
+            <a:avLst/>
+          </a:prstGeom>
+        </p:spPr>
+        <p:txBody>
+          <a:bodyPr anchor="t" wrap="square">
+            <a:normAutofit/>
+          </a:bodyPr>
+          <a:lstStyle/>
+          <a:p>
+            <a:pPr>
+              <a:buNone/>
+            </a:pPr>
+            <a:r>
+              <a:rPr lang="zh-HK" sz="2800" b="1">
+                <a:solidFill>
+                  <a:srgbClr val="F8FAFC"/>
+                </a:solidFill>
+              </a:rPr>
+              <a:t>安全主任 safety_officer</a:t>
+            </a:r>
+          </a:p>
+        </p:txBody>
+      </p:sp>
+      <p:sp>
+        <p:nvSpPr>
+          <p:cNvPr id="4" name="Body"/>
+          <p:cNvSpPr>
+            <a:spLocks noGrp="1"/>
+          </p:cNvSpPr>
+          <p:nvPr>
+            <p:ph type="body" idx="1"/>
+          </p:nvPr>
+        </p:nvSpPr>
+        <p:spPr>
+          <a:xfrm>
+            <a:off x="457200" y="1619250"/>
+            <a:ext cx="11277600" cy="4857750"/>
+          </a:xfrm>
+          <a:prstGeom prst="rect">
+            <a:avLst/>
+          </a:prstGeom>
+        </p:spPr>
+        <p:txBody>
+          <a:bodyPr anchor="t" wrap="square">
+            <a:normAutofit/>
+          </a:bodyPr>
+          <a:lstStyle/>
+          <a:p>
+            <a:pPr>
+              <a:buNone/>
+            </a:pPr>
+            <a:r>
+              <a:rPr lang="zh-HK" sz="1600" b="1">
+                <a:solidFill>
+                  <a:srgbClr val="F97316"/>
+                </a:solidFill>
+              </a:rPr>
+              <a:t>動火 / 高空 / 吊運證 OK，QR 掃描 + 簽名證明好正</a:t>
+            </a:r>
+          </a:p>
+          <a:p>
+            <a:pPr>
+              <a:buNone/>
+            </a:pPr>
+            <a:endParaRPr lang="zh-HK" sz="600"/>
+          </a:p>
+          <a:p>
+            <a:pPr marL="285750" indent="-285750">
+              <a:buFont typeface="Arial"/>
+              <a:buChar char="•"/>
+            </a:pPr>
+            <a:r>
+              <a:rPr lang="zh-HK" sz="1400">
+                <a:solidFill>
+                  <a:srgbClr val="E2E8F0"/>
+                </a:solidFill>
+              </a:rPr>
+              <a:t>👍 最啱用：工作許可證 PTW + 現場 QR 掃描核實 + 電子簽名證本人</a:t>
+            </a:r>
+          </a:p>
+          <a:p>
+            <a:pPr marL="285750" indent="-285750">
+              <a:buFont typeface="Arial"/>
+              <a:buChar char="•"/>
+            </a:pPr>
+            <a:r>
+              <a:rPr lang="zh-HK" sz="1400">
+                <a:solidFill>
+                  <a:srgbClr val="E2E8F0"/>
+                </a:solidFill>
+              </a:rPr>
+              <a:t>💢 痛點被殺：以前許可證紙簽，邊個簽過、幾時到期靠人記 —— 而家系統卡住 + 自動到期</a:t>
+            </a:r>
+          </a:p>
+          <a:p>
+            <a:pPr marL="285750" indent="-285750">
+              <a:buFont typeface="Arial"/>
+              <a:buChar char="•"/>
+            </a:pPr>
+            <a:r>
+              <a:rPr lang="zh-HK" sz="1400">
+                <a:solidFill>
+                  <a:srgbClr val="E2E8F0"/>
+                </a:solidFill>
+              </a:rPr>
+              <a:t>🛠 想改善：密閉空間 / 掘地證起初開唔到（渠務地盤靠呢兩款）+ 氣體測試 O2/H2S/CO/LEL 睇唔到（已修）</a:t>
+            </a:r>
+          </a:p>
+          <a:p>
+            <a:pPr marL="285750" indent="-285750">
+              <a:buFont typeface="Arial"/>
+              <a:buChar char="•"/>
+            </a:pPr>
+            <a:r>
+              <a:rPr lang="zh-HK" sz="1400">
+                <a:solidFill>
+                  <a:srgbClr val="E2E8F0"/>
+                </a:solidFill>
+              </a:rPr>
+              <a:t>❓ 想問你：仲有邊幾款許可證 / 檢查表，你哋日日要用但系統未有？</a:t>
+            </a:r>
+          </a:p>
+          <a:p>
+            <a:pPr>
+              <a:buNone/>
+            </a:pPr>
+            <a:endParaRPr lang="zh-HK" sz="600"/>
+          </a:p>
+          <a:p>
+            <a:pPr>
+              <a:buNone/>
+            </a:pPr>
+            <a:r>
+              <a:rPr lang="zh-HK" sz="1000" i="1">
+                <a:solidFill>
+                  <a:srgbClr val="94A3B8"/>
+                </a:solidFill>
+              </a:rPr>
+              <a:t>講者備註 · 安全主任係合規關鍵。PTW + 到期自動化 + 簽名證明係佢嘅核心。掘地/密閉已補返。</a:t>
+            </a:r>
+          </a:p>
+        </p:txBody>
+      </p:sp>
+    </p:spTree>
+  </p:cSld>
+  <p:clrMapOvr>
+    <a:overrideClrMapping bg1="dk1" tx1="lt1" bg2="dk2" tx2="lt2" accent1="accent1" accent2="accent2" accent3="accent3" accent4="accent4" accent5="accent5" accent6="accent6" hlink="hlink" folHlink="folHlink"/>
+  </p:clrMapOvr>
+</p:sld>
+</file>
+
+<file path=ppt/slides/slide33.xml><?xml version="1.0" encoding="utf-8"?>
+<p:sld xmlns:a="http://schemas.openxmlformats.org/drawingml/2006/main" xmlns:r="http://schemas.openxmlformats.org/officeDocument/2006/relationships" xmlns:p="http://schemas.openxmlformats.org/presentationml/2006/main">
+  <p:cSld>
+    <p:bg>
+      <p:bgPr>
+        <a:solidFill>
+          <a:srgbClr val="0F172A"/>
+        </a:solidFill>
+        <a:effectLst/>
+      </p:bgPr>
+    </p:bg>
+    <p:spTree>
+      <p:nvGrpSpPr>
+        <p:cNvPr id="1" name=""/>
+        <p:cNvGrpSpPr/>
+        <p:nvPr/>
+      </p:nvGrpSpPr>
+      <p:grpSpPr>
+        <a:xfrm>
+          <a:off x="0" y="0"/>
+          <a:ext cx="12192000" cy="6858000"/>
+          <a:chOff x="0" y="0"/>
+          <a:chExt cx="12192000" cy="6858000"/>
+        </a:xfrm>
+      </p:grpSpPr>
+      <p:sp>
+        <p:nvSpPr>
+          <p:cNvPr id="2" name="AccentBar"/>
+          <p:cNvSpPr/>
+          <p:nvPr/>
+        </p:nvSpPr>
+        <p:spPr>
+          <a:xfrm>
+            <a:off x="0" y="0"/>
+            <a:ext cx="114300" cy="6858000"/>
+          </a:xfrm>
+          <a:prstGeom prst="rect">
+            <a:avLst/>
+          </a:prstGeom>
+          <a:solidFill>
+            <a:srgbClr val="F97316"/>
+          </a:solidFill>
+        </p:spPr>
+        <p:txBody>
+          <a:bodyPr/>
+          <a:lstStyle/>
+          <a:p>
+            <a:endParaRPr lang="zh-HK"/>
+          </a:p>
+        </p:txBody>
+      </p:sp>
+      <p:sp>
+        <p:nvSpPr>
+          <p:cNvPr id="3" name="Title"/>
+          <p:cNvSpPr>
+            <a:spLocks noGrp="1"/>
+          </p:cNvSpPr>
+          <p:nvPr>
+            <p:ph type="title"/>
+          </p:nvPr>
+        </p:nvSpPr>
+        <p:spPr>
+          <a:xfrm>
+            <a:off x="457200" y="381000"/>
+            <a:ext cx="11277600" cy="1143000"/>
+          </a:xfrm>
+          <a:prstGeom prst="rect">
+            <a:avLst/>
+          </a:prstGeom>
+        </p:spPr>
+        <p:txBody>
+          <a:bodyPr anchor="t" wrap="square">
+            <a:normAutofit/>
+          </a:bodyPr>
+          <a:lstStyle/>
+          <a:p>
+            <a:pPr>
+              <a:buNone/>
+            </a:pPr>
+            <a:r>
+              <a:rPr lang="zh-HK" sz="2800" b="1">
+                <a:solidFill>
+                  <a:srgbClr val="F8FAFC"/>
+                </a:solidFill>
+              </a:rPr>
+              <a:t>業主 owner</a:t>
+            </a:r>
+          </a:p>
+        </p:txBody>
+      </p:sp>
+      <p:sp>
+        <p:nvSpPr>
+          <p:cNvPr id="4" name="Body"/>
+          <p:cNvSpPr>
+            <a:spLocks noGrp="1"/>
+          </p:cNvSpPr>
+          <p:nvPr>
+            <p:ph type="body" idx="1"/>
+          </p:nvPr>
+        </p:nvSpPr>
+        <p:spPr>
+          <a:xfrm>
+            <a:off x="457200" y="1619250"/>
+            <a:ext cx="11277600" cy="4857750"/>
+          </a:xfrm>
+          <a:prstGeom prst="rect">
+            <a:avLst/>
+          </a:prstGeom>
+        </p:spPr>
+        <p:txBody>
+          <a:bodyPr anchor="t" wrap="square">
+            <a:normAutofit/>
+          </a:bodyPr>
+          <a:lstStyle/>
+          <a:p>
+            <a:pPr>
+              <a:buNone/>
+            </a:pPr>
+            <a:r>
+              <a:rPr lang="zh-HK" sz="1600" b="1">
+                <a:solidFill>
+                  <a:srgbClr val="F97316"/>
+                </a:solidFill>
+              </a:rPr>
+              <a:t>我多數唔開 app，淨係收 PM 嗰張一頁紙報告，唯讀，10 秒睇得明</a:t>
+            </a:r>
+          </a:p>
+          <a:p>
+            <a:pPr>
+              <a:buNone/>
+            </a:pPr>
+            <a:endParaRPr lang="zh-HK" sz="600"/>
+          </a:p>
+          <a:p>
+            <a:pPr marL="285750" indent="-285750">
+              <a:buFont typeface="Arial"/>
+              <a:buChar char="•"/>
+            </a:pPr>
+            <a:r>
+              <a:rPr lang="zh-HK" sz="1400">
+                <a:solidFill>
+                  <a:srgbClr val="E2E8F0"/>
+                </a:solidFill>
+              </a:rPr>
+              <a:t>👍 最啱用：一頁紙業主版報告，唯讀、唔使學、唔使落地盤都知做到邊</a:t>
+            </a:r>
+          </a:p>
+          <a:p>
+            <a:pPr marL="285750" indent="-285750">
+              <a:buFont typeface="Arial"/>
+              <a:buChar char="•"/>
+            </a:pPr>
+            <a:r>
+              <a:rPr lang="zh-HK" sz="1400">
+                <a:solidFill>
+                  <a:srgbClr val="E2E8F0"/>
+                </a:solidFill>
+              </a:rPr>
+              <a:t>💢 痛點被殺：以前要等 PM 開會 / 打電話先知進度 —— 而家一張紙睇晒</a:t>
+            </a:r>
+          </a:p>
+          <a:p>
+            <a:pPr marL="285750" indent="-285750">
+              <a:buFont typeface="Arial"/>
+              <a:buChar char="•"/>
+            </a:pPr>
+            <a:r>
+              <a:rPr lang="zh-HK" sz="1400">
+                <a:solidFill>
+                  <a:srgbClr val="E2E8F0"/>
+                </a:solidFill>
+              </a:rPr>
+              <a:t>🛠 想改善：EOT 工期延誤申索改唔到（淨係記錄者改到）</a:t>
+            </a:r>
+          </a:p>
+          <a:p>
+            <a:pPr marL="285750" indent="-285750">
+              <a:buFont typeface="Arial"/>
+              <a:buChar char="•"/>
+            </a:pPr>
+            <a:r>
+              <a:rPr lang="zh-HK" sz="1400">
+                <a:solidFill>
+                  <a:srgbClr val="E2E8F0"/>
+                </a:solidFill>
+              </a:rPr>
+              <a:t>❓ 想問你：業主想唔想收 app 通知（又延誤、又超支就 send），定淨係收報告就夠？</a:t>
+            </a:r>
+          </a:p>
+          <a:p>
+            <a:pPr>
+              <a:buNone/>
+            </a:pPr>
+            <a:endParaRPr lang="zh-HK" sz="600"/>
+          </a:p>
+          <a:p>
+            <a:pPr>
+              <a:buNone/>
+            </a:pPr>
+            <a:r>
+              <a:rPr lang="zh-HK" sz="1000" i="1">
+                <a:solidFill>
+                  <a:srgbClr val="94A3B8"/>
+                </a:solidFill>
+              </a:rPr>
+              <a:t>講者備註 · 業主係最唔肯學嘢嗰個。賣點就係佢咩都唔使做、收張紙。睇唔到內部細節係刻意。</a:t>
+            </a:r>
+          </a:p>
+        </p:txBody>
+      </p:sp>
+    </p:spTree>
+  </p:cSld>
+  <p:clrMapOvr>
+    <a:overrideClrMapping bg1="dk1" tx1="lt1" bg2="dk2" tx2="lt2" accent1="accent1" accent2="accent2" accent3="accent3" accent4="accent4" accent5="accent5" accent6="accent6" hlink="hlink" folHlink="folHlink"/>
+  </p:clrMapOvr>
+</p:sld>
+</file>
+
+<file path=ppt/slides/slide34.xml><?xml version="1.0" encoding="utf-8"?>
+<p:sld xmlns:a="http://schemas.openxmlformats.org/drawingml/2006/main" xmlns:r="http://schemas.openxmlformats.org/officeDocument/2006/relationships" xmlns:p="http://schemas.openxmlformats.org/presentationml/2006/main">
+  <p:cSld>
+    <p:bg>
+      <p:bgPr>
+        <a:solidFill>
+          <a:srgbClr val="0F172A"/>
+        </a:solidFill>
+        <a:effectLst/>
+      </p:bgPr>
+    </p:bg>
+    <p:spTree>
+      <p:nvGrpSpPr>
+        <p:cNvPr id="1" name=""/>
+        <p:cNvGrpSpPr/>
+        <p:nvPr/>
+      </p:nvGrpSpPr>
+      <p:grpSpPr>
+        <a:xfrm>
+          <a:off x="0" y="0"/>
+          <a:ext cx="12192000" cy="6858000"/>
+          <a:chOff x="0" y="0"/>
+          <a:chExt cx="12192000" cy="6858000"/>
+        </a:xfrm>
+      </p:grpSpPr>
+      <p:sp>
+        <p:nvSpPr>
+          <p:cNvPr id="2" name="AccentBar"/>
+          <p:cNvSpPr/>
+          <p:nvPr/>
+        </p:nvSpPr>
+        <p:spPr>
+          <a:xfrm>
+            <a:off x="0" y="0"/>
+            <a:ext cx="114300" cy="6858000"/>
+          </a:xfrm>
+          <a:prstGeom prst="rect">
+            <a:avLst/>
+          </a:prstGeom>
+          <a:solidFill>
+            <a:srgbClr val="F97316"/>
+          </a:solidFill>
+        </p:spPr>
+        <p:txBody>
+          <a:bodyPr/>
+          <a:lstStyle/>
+          <a:p>
+            <a:endParaRPr lang="zh-HK"/>
+          </a:p>
+        </p:txBody>
+      </p:sp>
+      <p:sp>
+        <p:nvSpPr>
+          <p:cNvPr id="3" name="Title"/>
+          <p:cNvSpPr>
+            <a:spLocks noGrp="1"/>
+          </p:cNvSpPr>
+          <p:nvPr>
+            <p:ph type="title"/>
+          </p:nvPr>
+        </p:nvSpPr>
+        <p:spPr>
+          <a:xfrm>
+            <a:off x="457200" y="381000"/>
+            <a:ext cx="11277600" cy="1143000"/>
+          </a:xfrm>
+          <a:prstGeom prst="rect">
+            <a:avLst/>
+          </a:prstGeom>
+        </p:spPr>
+        <p:txBody>
+          <a:bodyPr anchor="t" wrap="square">
+            <a:normAutofit/>
+          </a:bodyPr>
+          <a:lstStyle/>
+          <a:p>
+            <a:pPr>
+              <a:buNone/>
+            </a:pPr>
+            <a:r>
+              <a:rPr lang="zh-HK" sz="2800" b="1">
+                <a:solidFill>
+                  <a:srgbClr val="F8FAFC"/>
+                </a:solidFill>
+              </a:rPr>
+              <a:t>系統管理員 admin</a:t>
+            </a:r>
+          </a:p>
+        </p:txBody>
+      </p:sp>
+      <p:sp>
+        <p:nvSpPr>
+          <p:cNvPr id="4" name="Body"/>
+          <p:cNvSpPr>
+            <a:spLocks noGrp="1"/>
+          </p:cNvSpPr>
+          <p:nvPr>
+            <p:ph type="body" idx="1"/>
+          </p:nvPr>
+        </p:nvSpPr>
+        <p:spPr>
+          <a:xfrm>
+            <a:off x="457200" y="1619250"/>
+            <a:ext cx="11277600" cy="4857750"/>
+          </a:xfrm>
+          <a:prstGeom prst="rect">
+            <a:avLst/>
+          </a:prstGeom>
+        </p:spPr>
+        <p:txBody>
+          <a:bodyPr anchor="t" wrap="square">
+            <a:normAutofit/>
+          </a:bodyPr>
+          <a:lstStyle/>
+          <a:p>
+            <a:pPr>
+              <a:buNone/>
+            </a:pPr>
+            <a:r>
+              <a:rPr lang="zh-HK" sz="1600" b="1">
+                <a:solidFill>
+                  <a:srgbClr val="F97316"/>
+                </a:solidFill>
+              </a:rPr>
+              <a:t>我開盤、設分區、派 PM、開關 13 個模組</a:t>
+            </a:r>
+          </a:p>
+          <a:p>
+            <a:pPr>
+              <a:buNone/>
+            </a:pPr>
+            <a:endParaRPr lang="zh-HK" sz="600"/>
+          </a:p>
+          <a:p>
+            <a:pPr marL="285750" indent="-285750">
+              <a:buFont typeface="Arial"/>
+              <a:buChar char="•"/>
+            </a:pPr>
+            <a:r>
+              <a:rPr lang="zh-HK" sz="1400">
+                <a:solidFill>
+                  <a:srgbClr val="E2E8F0"/>
+                </a:solidFill>
+              </a:rPr>
+              <a:t>👍 最啱用：13 個模組逐個地盤開關 + 防篡改審計 proof</a:t>
+            </a:r>
+          </a:p>
+          <a:p>
+            <a:pPr marL="285750" indent="-285750">
+              <a:buFont typeface="Arial"/>
+              <a:buChar char="•"/>
+            </a:pPr>
+            <a:r>
+              <a:rPr lang="zh-HK" sz="1400">
+                <a:solidFill>
+                  <a:srgbClr val="E2E8F0"/>
+                </a:solidFill>
+              </a:rPr>
+              <a:t>💢 痛點被殺：以前唔同地盤想要唔同功能冇得揀 —— 而家逐盤 on/off</a:t>
+            </a:r>
+          </a:p>
+          <a:p>
+            <a:pPr marL="285750" indent="-285750">
+              <a:buFont typeface="Arial"/>
+              <a:buChar char="•"/>
+            </a:pPr>
+            <a:r>
+              <a:rPr lang="zh-HK" sz="1400">
+                <a:solidFill>
+                  <a:srgbClr val="E2E8F0"/>
+                </a:solidFill>
+              </a:rPr>
+              <a:t>🛠 想改善：防篡改 proof 喺手機（Capacitor）匯出㩒咗冇反應；關咗模組之後有啲數靜靜少計、冇提示（已修）</a:t>
+            </a:r>
+          </a:p>
+          <a:p>
+            <a:pPr marL="285750" indent="-285750">
+              <a:buFont typeface="Arial"/>
+              <a:buChar char="•"/>
+            </a:pPr>
+            <a:r>
+              <a:rPr lang="zh-HK" sz="1400">
+                <a:solidFill>
+                  <a:srgbClr val="E2E8F0"/>
+                </a:solidFill>
+              </a:rPr>
+              <a:t>❓ 想問你：13 個模組會唔會太多？邊幾個係必開、邊幾個其實冇人用？</a:t>
+            </a:r>
+          </a:p>
+          <a:p>
+            <a:pPr>
+              <a:buNone/>
+            </a:pPr>
+            <a:endParaRPr lang="zh-HK" sz="600"/>
+          </a:p>
+          <a:p>
+            <a:pPr>
+              <a:buNone/>
+            </a:pPr>
+            <a:r>
+              <a:rPr lang="zh-HK" sz="1000" i="1">
+                <a:solidFill>
+                  <a:srgbClr val="94A3B8"/>
+                </a:solidFill>
+              </a:rPr>
+              <a:t>講者備註 · admin 係買單同 setup 嗰個。模組開關 = 賣俾唔同規模地盤嘅彈性。</a:t>
+            </a:r>
+          </a:p>
+        </p:txBody>
+      </p:sp>
+    </p:spTree>
+  </p:cSld>
+  <p:clrMapOvr>
+    <a:overrideClrMapping bg1="dk1" tx1="lt1" bg2="dk2" tx2="lt2" accent1="accent1" accent2="accent2" accent3="accent3" accent4="accent4" accent5="accent5" accent6="accent6" hlink="hlink" folHlink="folHlink"/>
+  </p:clrMapOvr>
+</p:sld>
+</file>
+
+<file path=ppt/slides/slide35.xml><?xml version="1.0" encoding="utf-8"?>
+<p:sld xmlns:a="http://schemas.openxmlformats.org/drawingml/2006/main" xmlns:r="http://schemas.openxmlformats.org/officeDocument/2006/relationships" xmlns:p="http://schemas.openxmlformats.org/presentationml/2006/main">
+  <p:cSld>
+    <p:bg>
+      <p:bgPr>
+        <a:solidFill>
+          <a:srgbClr val="0F172A"/>
+        </a:solidFill>
+        <a:effectLst/>
+      </p:bgPr>
+    </p:bg>
+    <p:spTree>
+      <p:nvGrpSpPr>
+        <p:cNvPr id="1" name=""/>
+        <p:cNvGrpSpPr/>
+        <p:nvPr/>
+      </p:nvGrpSpPr>
+      <p:grpSpPr>
+        <a:xfrm>
+          <a:off x="0" y="0"/>
+          <a:ext cx="12192000" cy="6858000"/>
+          <a:chOff x="0" y="0"/>
+          <a:chExt cx="12192000" cy="6858000"/>
+        </a:xfrm>
+      </p:grpSpPr>
+      <p:sp>
+        <p:nvSpPr>
+          <p:cNvPr id="2" name="AccentBar"/>
+          <p:cNvSpPr/>
+          <p:nvPr/>
+        </p:nvSpPr>
+        <p:spPr>
+          <a:xfrm>
+            <a:off x="0" y="0"/>
+            <a:ext cx="114300" cy="6858000"/>
+          </a:xfrm>
+          <a:prstGeom prst="rect">
+            <a:avLst/>
+          </a:prstGeom>
+          <a:solidFill>
+            <a:srgbClr val="F97316"/>
+          </a:solidFill>
+        </p:spPr>
+        <p:txBody>
+          <a:bodyPr/>
+          <a:lstStyle/>
+          <a:p>
+            <a:endParaRPr lang="zh-HK"/>
+          </a:p>
+        </p:txBody>
+      </p:sp>
+      <p:sp>
+        <p:nvSpPr>
+          <p:cNvPr id="3" name="Title"/>
+          <p:cNvSpPr>
+            <a:spLocks noGrp="1"/>
+          </p:cNvSpPr>
+          <p:nvPr>
+            <p:ph type="title"/>
+          </p:nvPr>
+        </p:nvSpPr>
+        <p:spPr>
+          <a:xfrm>
+            <a:off x="457200" y="381000"/>
+            <a:ext cx="11277600" cy="1143000"/>
+          </a:xfrm>
+          <a:prstGeom prst="rect">
+            <a:avLst/>
+          </a:prstGeom>
+        </p:spPr>
+        <p:txBody>
+          <a:bodyPr anchor="t" wrap="square">
+            <a:normAutofit/>
+          </a:bodyPr>
+          <a:lstStyle/>
+          <a:p>
+            <a:pPr>
+              <a:buNone/>
+            </a:pPr>
+            <a:r>
+              <a:rPr lang="zh-HK" sz="3600" b="1">
+                <a:solidFill>
+                  <a:srgbClr val="F8FAFC"/>
+                </a:solidFill>
+              </a:rPr>
+              <a:t>研討問題 —— 想聽你哋講</a:t>
+            </a:r>
+          </a:p>
+        </p:txBody>
+      </p:sp>
+      <p:sp>
+        <p:nvSpPr>
+          <p:cNvPr id="4" name="Body"/>
+          <p:cNvSpPr>
+            <a:spLocks noGrp="1"/>
+          </p:cNvSpPr>
+          <p:nvPr>
+            <p:ph type="body" idx="1"/>
+          </p:nvPr>
+        </p:nvSpPr>
+        <p:spPr>
+          <a:xfrm>
+            <a:off x="457200" y="1619250"/>
+            <a:ext cx="11277600" cy="4857750"/>
+          </a:xfrm>
+          <a:prstGeom prst="rect">
+            <a:avLst/>
+          </a:prstGeom>
+        </p:spPr>
+        <p:txBody>
+          <a:bodyPr anchor="t" wrap="square">
+            <a:normAutofit/>
+          </a:bodyPr>
+          <a:lstStyle/>
+          <a:p>
+            <a:pPr>
+              <a:buNone/>
+            </a:pPr>
+            <a:r>
+              <a:rPr lang="zh-HK" sz="1600" b="1">
+                <a:solidFill>
+                  <a:srgbClr val="F97316"/>
+                </a:solidFill>
+              </a:rPr>
+              <a:t>唔係 demo 完散水，係想攞你哋真實 feedback</a:t>
+            </a:r>
+          </a:p>
+          <a:p>
+            <a:pPr>
+              <a:buNone/>
+            </a:pPr>
+            <a:endParaRPr lang="zh-HK" sz="600"/>
+          </a:p>
+          <a:p>
+            <a:pPr marL="285750" indent="-285750">
+              <a:buFont typeface="Arial"/>
+              <a:buChar char="•"/>
+            </a:pPr>
+            <a:r>
+              <a:rPr lang="zh-HK" sz="1400">
+                <a:solidFill>
+                  <a:srgbClr val="E2E8F0"/>
+                </a:solidFill>
+              </a:rPr>
+              <a:t>跟住兩張，係留俾你哋答嘅 —— 功能向 + 落地向</a:t>
+            </a:r>
+          </a:p>
+          <a:p>
+            <a:pPr marL="285750" indent="-285750">
+              <a:buFont typeface="Arial"/>
+              <a:buChar char="•"/>
+            </a:pPr>
+            <a:r>
+              <a:rPr lang="zh-HK" sz="1400">
+                <a:solidFill>
+                  <a:srgbClr val="E2E8F0"/>
+                </a:solidFill>
+              </a:rPr>
+              <a:t>邊題啱你崗位就答邊題，無分對錯</a:t>
+            </a:r>
+          </a:p>
+          <a:p>
+            <a:pPr>
+              <a:buNone/>
+            </a:pPr>
+            <a:endParaRPr lang="zh-HK" sz="600"/>
+          </a:p>
+          <a:p>
+            <a:pPr>
+              <a:buNone/>
+            </a:pPr>
+            <a:r>
+              <a:rPr lang="zh-HK" sz="1000" i="1">
+                <a:solidFill>
+                  <a:srgbClr val="94A3B8"/>
+                </a:solidFill>
+              </a:rPr>
+              <a:t>講者備註 · 過場。轉場做互動環節。可以即場派紙仔或者開 WhatsApp group 收答案。</a:t>
+            </a:r>
+          </a:p>
+        </p:txBody>
+      </p:sp>
+    </p:spTree>
+  </p:cSld>
+  <p:clrMapOvr>
+    <a:overrideClrMapping bg1="dk1" tx1="lt1" bg2="dk2" tx2="lt2" accent1="accent1" accent2="accent2" accent3="accent3" accent4="accent4" accent5="accent5" accent6="accent6" hlink="hlink" folHlink="folHlink"/>
+  </p:clrMapOvr>
+</p:sld>
+</file>
+
+<file path=ppt/slides/slide36.xml><?xml version="1.0" encoding="utf-8"?>
+<p:sld xmlns:a="http://schemas.openxmlformats.org/drawingml/2006/main" xmlns:r="http://schemas.openxmlformats.org/officeDocument/2006/relationships" xmlns:p="http://schemas.openxmlformats.org/presentationml/2006/main">
+  <p:cSld>
+    <p:bg>
+      <p:bgPr>
+        <a:solidFill>
+          <a:srgbClr val="0F172A"/>
+        </a:solidFill>
+        <a:effectLst/>
+      </p:bgPr>
+    </p:bg>
+    <p:spTree>
+      <p:nvGrpSpPr>
+        <p:cNvPr id="1" name=""/>
+        <p:cNvGrpSpPr/>
+        <p:nvPr/>
+      </p:nvGrpSpPr>
+      <p:grpSpPr>
+        <a:xfrm>
+          <a:off x="0" y="0"/>
+          <a:ext cx="12192000" cy="6858000"/>
+          <a:chOff x="0" y="0"/>
+          <a:chExt cx="12192000" cy="6858000"/>
+        </a:xfrm>
+      </p:grpSpPr>
+      <p:sp>
+        <p:nvSpPr>
+          <p:cNvPr id="2" name="AccentBar"/>
+          <p:cNvSpPr/>
+          <p:nvPr/>
+        </p:nvSpPr>
+        <p:spPr>
+          <a:xfrm>
+            <a:off x="0" y="0"/>
+            <a:ext cx="114300" cy="6858000"/>
+          </a:xfrm>
+          <a:prstGeom prst="rect">
+            <a:avLst/>
+          </a:prstGeom>
+          <a:solidFill>
+            <a:srgbClr val="F97316"/>
+          </a:solidFill>
+        </p:spPr>
+        <p:txBody>
+          <a:bodyPr/>
+          <a:lstStyle/>
+          <a:p>
+            <a:endParaRPr lang="zh-HK"/>
+          </a:p>
+        </p:txBody>
+      </p:sp>
+      <p:sp>
+        <p:nvSpPr>
+          <p:cNvPr id="3" name="Title"/>
+          <p:cNvSpPr>
+            <a:spLocks noGrp="1"/>
+          </p:cNvSpPr>
+          <p:nvPr>
+            <p:ph type="title"/>
+          </p:nvPr>
+        </p:nvSpPr>
+        <p:spPr>
+          <a:xfrm>
+            <a:off x="457200" y="381000"/>
+            <a:ext cx="11277600" cy="1143000"/>
+          </a:xfrm>
+          <a:prstGeom prst="rect">
+            <a:avLst/>
+          </a:prstGeom>
+        </p:spPr>
+        <p:txBody>
+          <a:bodyPr anchor="t" wrap="square">
+            <a:normAutofit/>
+          </a:bodyPr>
+          <a:lstStyle/>
+          <a:p>
+            <a:pPr>
+              <a:buNone/>
+            </a:pPr>
+            <a:r>
+              <a:rPr lang="zh-HK" sz="2800" b="1">
+                <a:solidFill>
+                  <a:srgbClr val="F8FAFC"/>
+                </a:solidFill>
+              </a:rPr>
+              <a:t>畀你哋嘅問題（功能向）</a:t>
+            </a:r>
+          </a:p>
+        </p:txBody>
+      </p:sp>
+      <p:sp>
+        <p:nvSpPr>
+          <p:cNvPr id="4" name="Body"/>
+          <p:cNvSpPr>
+            <a:spLocks noGrp="1"/>
+          </p:cNvSpPr>
+          <p:nvPr>
+            <p:ph type="body" idx="1"/>
+          </p:nvPr>
+        </p:nvSpPr>
+        <p:spPr>
+          <a:xfrm>
+            <a:off x="457200" y="1619250"/>
+            <a:ext cx="11277600" cy="4857750"/>
+          </a:xfrm>
+          <a:prstGeom prst="rect">
+            <a:avLst/>
+          </a:prstGeom>
+        </p:spPr>
+        <p:txBody>
+          <a:bodyPr anchor="t" wrap="square">
+            <a:normAutofit/>
+          </a:bodyPr>
+          <a:lstStyle/>
+          <a:p>
+            <a:pPr>
+              <a:buNone/>
+            </a:pPr>
+            <a:r>
+              <a:rPr lang="zh-HK" sz="1600" b="1">
+                <a:solidFill>
+                  <a:srgbClr val="F97316"/>
+                </a:solidFill>
+              </a:rPr>
+              <a:t>邊樣係剛需、邊樣係多餘？</a:t>
+            </a:r>
+          </a:p>
+          <a:p>
+            <a:pPr>
+              <a:buNone/>
+            </a:pPr>
+            <a:endParaRPr lang="zh-HK" sz="600"/>
+          </a:p>
+          <a:p>
+            <a:pPr marL="285750" indent="-285750">
+              <a:buFont typeface="Arial"/>
+              <a:buChar char="•"/>
+            </a:pPr>
+            <a:r>
+              <a:rPr lang="zh-HK" sz="1400">
+                <a:solidFill>
+                  <a:srgbClr val="E2E8F0"/>
+                </a:solidFill>
+              </a:rPr>
+              <a:t>❓ 邊個 function 對你最有用 —— 少咗佢你就唔會用呢個 app？</a:t>
+            </a:r>
+          </a:p>
+          <a:p>
+            <a:pPr marL="285750" indent="-285750">
+              <a:buFont typeface="Arial"/>
+              <a:buChar char="•"/>
+            </a:pPr>
+            <a:r>
+              <a:rPr lang="zh-HK" sz="1400">
+                <a:solidFill>
+                  <a:srgbClr val="E2E8F0"/>
+                </a:solidFill>
+              </a:rPr>
+              <a:t>❓ 你而家最大嘅地盤痛點係咩？呢個系統殺唔殺到？殺到幾多成？</a:t>
+            </a:r>
+          </a:p>
+          <a:p>
+            <a:pPr marL="285750" indent="-285750">
+              <a:buFont typeface="Arial"/>
+              <a:buChar char="•"/>
+            </a:pPr>
+            <a:r>
+              <a:rPr lang="zh-HK" sz="1400">
+                <a:solidFill>
+                  <a:srgbClr val="E2E8F0"/>
+                </a:solidFill>
+              </a:rPr>
+              <a:t>❓ 邊個 function 你覺得你唔會用，或者要大改先用得著？</a:t>
+            </a:r>
+          </a:p>
+          <a:p>
+            <a:pPr marL="285750" indent="-285750">
+              <a:buFont typeface="Arial"/>
+              <a:buChar char="•"/>
+            </a:pPr>
+            <a:r>
+              <a:rPr lang="zh-HK" sz="1400">
+                <a:solidFill>
+                  <a:srgbClr val="E2E8F0"/>
+                </a:solidFill>
+              </a:rPr>
+              <a:t>❓ 有冇咩嘢你日日做、但系統而家完全冇 cover？</a:t>
+            </a:r>
+          </a:p>
+          <a:p>
+            <a:pPr marL="285750" indent="-285750">
+              <a:buFont typeface="Arial"/>
+              <a:buChar char="•"/>
+            </a:pPr>
+            <a:r>
+              <a:rPr lang="zh-HK" sz="1400">
+                <a:solidFill>
+                  <a:srgbClr val="E2E8F0"/>
+                </a:solidFill>
+              </a:rPr>
+              <a:t>❓ 你最唔放心交俾 app 嘅係邊一 part —— 簽名？金額？相？進度數字？</a:t>
+            </a:r>
+          </a:p>
+          <a:p>
+            <a:pPr>
+              <a:buNone/>
+            </a:pPr>
+            <a:endParaRPr lang="zh-HK" sz="600"/>
+          </a:p>
+          <a:p>
+            <a:pPr>
+              <a:buNone/>
+            </a:pPr>
+            <a:r>
+              <a:rPr lang="zh-HK" sz="1000" i="1">
+                <a:solidFill>
+                  <a:srgbClr val="94A3B8"/>
+                </a:solidFill>
+              </a:rPr>
+              <a:t>講者備註 · 逐題停低收答案。第 1、3 題最值錢：話我知邊個功能係核心、邊個係 dead weight 可以砍。</a:t>
+            </a:r>
+          </a:p>
+        </p:txBody>
+      </p:sp>
+    </p:spTree>
+  </p:cSld>
+  <p:clrMapOvr>
+    <a:overrideClrMapping bg1="dk1" tx1="lt1" bg2="dk2" tx2="lt2" accent1="accent1" accent2="accent2" accent3="accent3" accent4="accent4" accent5="accent5" accent6="accent6" hlink="hlink" folHlink="folHlink"/>
+  </p:clrMapOvr>
+</p:sld>
+</file>
+
+<file path=ppt/slides/slide37.xml><?xml version="1.0" encoding="utf-8"?>
+<p:sld xmlns:a="http://schemas.openxmlformats.org/drawingml/2006/main" xmlns:r="http://schemas.openxmlformats.org/officeDocument/2006/relationships" xmlns:p="http://schemas.openxmlformats.org/presentationml/2006/main">
+  <p:cSld>
+    <p:bg>
+      <p:bgPr>
+        <a:solidFill>
+          <a:srgbClr val="0F172A"/>
+        </a:solidFill>
+        <a:effectLst/>
+      </p:bgPr>
+    </p:bg>
+    <p:spTree>
+      <p:nvGrpSpPr>
+        <p:cNvPr id="1" name=""/>
+        <p:cNvGrpSpPr/>
+        <p:nvPr/>
+      </p:nvGrpSpPr>
+      <p:grpSpPr>
+        <a:xfrm>
+          <a:off x="0" y="0"/>
+          <a:ext cx="12192000" cy="6858000"/>
+          <a:chOff x="0" y="0"/>
+          <a:chExt cx="12192000" cy="6858000"/>
+        </a:xfrm>
+      </p:grpSpPr>
+      <p:sp>
+        <p:nvSpPr>
+          <p:cNvPr id="2" name="AccentBar"/>
+          <p:cNvSpPr/>
+          <p:nvPr/>
+        </p:nvSpPr>
+        <p:spPr>
+          <a:xfrm>
+            <a:off x="0" y="0"/>
+            <a:ext cx="114300" cy="6858000"/>
+          </a:xfrm>
+          <a:prstGeom prst="rect">
+            <a:avLst/>
+          </a:prstGeom>
+          <a:solidFill>
+            <a:srgbClr val="F97316"/>
+          </a:solidFill>
+        </p:spPr>
+        <p:txBody>
+          <a:bodyPr/>
+          <a:lstStyle/>
+          <a:p>
+            <a:endParaRPr lang="zh-HK"/>
+          </a:p>
+        </p:txBody>
+      </p:sp>
+      <p:sp>
+        <p:nvSpPr>
+          <p:cNvPr id="3" name="Title"/>
+          <p:cNvSpPr>
+            <a:spLocks noGrp="1"/>
+          </p:cNvSpPr>
+          <p:nvPr>
+            <p:ph type="title"/>
+          </p:nvPr>
+        </p:nvSpPr>
+        <p:spPr>
+          <a:xfrm>
+            <a:off x="457200" y="381000"/>
+            <a:ext cx="11277600" cy="1143000"/>
+          </a:xfrm>
+          <a:prstGeom prst="rect">
+            <a:avLst/>
+          </a:prstGeom>
+        </p:spPr>
+        <p:txBody>
+          <a:bodyPr anchor="t" wrap="square">
+            <a:normAutofit/>
+          </a:bodyPr>
+          <a:lstStyle/>
+          <a:p>
+            <a:pPr>
+              <a:buNone/>
+            </a:pPr>
+            <a:r>
+              <a:rPr lang="zh-HK" sz="2800" b="1">
+                <a:solidFill>
+                  <a:srgbClr val="F8FAFC"/>
+                </a:solidFill>
+              </a:rPr>
+              <a:t>畀你哋嘅問題（落地向）</a:t>
+            </a:r>
+          </a:p>
+        </p:txBody>
+      </p:sp>
+      <p:sp>
+        <p:nvSpPr>
+          <p:cNvPr id="4" name="Body"/>
+          <p:cNvSpPr>
+            <a:spLocks noGrp="1"/>
+          </p:cNvSpPr>
+          <p:nvPr>
+            <p:ph type="body" idx="1"/>
+          </p:nvPr>
+        </p:nvSpPr>
+        <p:spPr>
+          <a:xfrm>
+            <a:off x="457200" y="1619250"/>
+            <a:ext cx="11277600" cy="4857750"/>
+          </a:xfrm>
+          <a:prstGeom prst="rect">
+            <a:avLst/>
+          </a:prstGeom>
+        </p:spPr>
+        <p:txBody>
+          <a:bodyPr anchor="t" wrap="square">
+            <a:normAutofit/>
+          </a:bodyPr>
+          <a:lstStyle/>
+          <a:p>
+            <a:pPr>
+              <a:buNone/>
+            </a:pPr>
+            <a:r>
+              <a:rPr lang="zh-HK" sz="1600" b="1">
+                <a:solidFill>
+                  <a:srgbClr val="F97316"/>
+                </a:solidFill>
+              </a:rPr>
+              <a:t>轉用呢個，真實阻力喺邊？</a:t>
+            </a:r>
+          </a:p>
+          <a:p>
+            <a:pPr>
+              <a:buNone/>
+            </a:pPr>
+            <a:endParaRPr lang="zh-HK" sz="600"/>
+          </a:p>
+          <a:p>
+            <a:pPr marL="285750" indent="-285750">
+              <a:buFont typeface="Arial"/>
+              <a:buChar char="•"/>
+            </a:pPr>
+            <a:r>
+              <a:rPr lang="zh-HK" sz="1400">
+                <a:solidFill>
+                  <a:srgbClr val="E2E8F0"/>
+                </a:solidFill>
+              </a:rPr>
+              <a:t>❓ 由 WhatsApp + 紙轉用呢個，最大阻力會係邊個崗位？</a:t>
+            </a:r>
+          </a:p>
+          <a:p>
+            <a:pPr marL="285750" indent="-285750">
+              <a:buFont typeface="Arial"/>
+              <a:buChar char="•"/>
+            </a:pPr>
+            <a:r>
+              <a:rPr lang="zh-HK" sz="1400">
+                <a:solidFill>
+                  <a:srgbClr val="E2E8F0"/>
+                </a:solidFill>
+              </a:rPr>
+              <a:t>❓ 邊個崗位最難 onboard（學唔識 / 唔肯用）？點先肯用？</a:t>
+            </a:r>
+          </a:p>
+          <a:p>
+            <a:pPr marL="285750" indent="-285750">
+              <a:buFont typeface="Arial"/>
+              <a:buChar char="•"/>
+            </a:pPr>
+            <a:r>
+              <a:rPr lang="zh-HK" sz="1400">
+                <a:solidFill>
+                  <a:srgbClr val="E2E8F0"/>
+                </a:solidFill>
+              </a:rPr>
+              <a:t>❓ 你肯為咗「審計軌跡、爭拗有證據」放棄幾多「快同方便」？</a:t>
+            </a:r>
+          </a:p>
+          <a:p>
+            <a:pPr marL="285750" indent="-285750">
+              <a:buFont typeface="Arial"/>
+              <a:buChar char="•"/>
+            </a:pPr>
+            <a:r>
+              <a:rPr lang="zh-HK" sz="1400">
+                <a:solidFill>
+                  <a:srgbClr val="E2E8F0"/>
+                </a:solidFill>
+              </a:rPr>
+              <a:t>❓ 收費點計你先覺得抵 —— 逐個地盤？逐個 user？定逐個月？</a:t>
+            </a:r>
+          </a:p>
+          <a:p>
+            <a:pPr marL="285750" indent="-285750">
+              <a:buFont typeface="Arial"/>
+              <a:buChar char="•"/>
+            </a:pPr>
+            <a:r>
+              <a:rPr lang="zh-HK" sz="1400">
+                <a:solidFill>
+                  <a:srgbClr val="E2E8F0"/>
+                </a:solidFill>
+              </a:rPr>
+              <a:t>❓ 邊樣嘢一日未做到，你都唔會全盤轉用？</a:t>
+            </a:r>
+          </a:p>
+          <a:p>
+            <a:pPr>
+              <a:buNone/>
+            </a:pPr>
+            <a:endParaRPr lang="zh-HK" sz="600"/>
+          </a:p>
+          <a:p>
+            <a:pPr>
+              <a:buNone/>
+            </a:pPr>
+            <a:r>
+              <a:rPr lang="zh-HK" sz="1000" i="1">
+                <a:solidFill>
+                  <a:srgbClr val="94A3B8"/>
+                </a:solidFill>
+              </a:rPr>
+              <a:t>講者備註 · 呢度係 sales/pricing 情報。第 4 題直接問銷售模式，第 5 題問 deal-breaker。</a:t>
+            </a:r>
+          </a:p>
+        </p:txBody>
+      </p:sp>
+    </p:spTree>
+  </p:cSld>
+  <p:clrMapOvr>
+    <a:overrideClrMapping bg1="dk1" tx1="lt1" bg2="dk2" tx2="lt2" accent1="accent1" accent2="accent2" accent3="accent3" accent4="accent4" accent5="accent5" accent6="accent6" hlink="hlink" folHlink="folHlink"/>
+  </p:clrMapOvr>
+</p:sld>
+</file>
+
+<file path=ppt/slides/slide38.xml><?xml version="1.0" encoding="utf-8"?>
+<p:sld xmlns:a="http://schemas.openxmlformats.org/drawingml/2006/main" xmlns:r="http://schemas.openxmlformats.org/officeDocument/2006/relationships" xmlns:p="http://schemas.openxmlformats.org/presentationml/2006/main">
+  <p:cSld>
+    <p:bg>
+      <p:bgPr>
+        <a:solidFill>
+          <a:srgbClr val="0F172A"/>
+        </a:solidFill>
+        <a:effectLst/>
+      </p:bgPr>
+    </p:bg>
+    <p:spTree>
+      <p:nvGrpSpPr>
+        <p:cNvPr id="1" name=""/>
+        <p:cNvGrpSpPr/>
+        <p:nvPr/>
+      </p:nvGrpSpPr>
+      <p:grpSpPr>
+        <a:xfrm>
+          <a:off x="0" y="0"/>
+          <a:ext cx="12192000" cy="6858000"/>
+          <a:chOff x="0" y="0"/>
+          <a:chExt cx="12192000" cy="6858000"/>
+        </a:xfrm>
+      </p:grpSpPr>
+      <p:sp>
+        <p:nvSpPr>
+          <p:cNvPr id="2" name="AccentBar"/>
+          <p:cNvSpPr/>
+          <p:nvPr/>
+        </p:nvSpPr>
+        <p:spPr>
+          <a:xfrm>
+            <a:off x="0" y="0"/>
+            <a:ext cx="114300" cy="6858000"/>
+          </a:xfrm>
+          <a:prstGeom prst="rect">
+            <a:avLst/>
+          </a:prstGeom>
+          <a:solidFill>
+            <a:srgbClr val="F97316"/>
+          </a:solidFill>
+        </p:spPr>
+        <p:txBody>
+          <a:bodyPr/>
+          <a:lstStyle/>
+          <a:p>
+            <a:endParaRPr lang="zh-HK"/>
+          </a:p>
+        </p:txBody>
+      </p:sp>
+      <p:sp>
+        <p:nvSpPr>
+          <p:cNvPr id="3" name="Title"/>
+          <p:cNvSpPr>
+            <a:spLocks noGrp="1"/>
+          </p:cNvSpPr>
+          <p:nvPr>
+            <p:ph type="title"/>
+          </p:nvPr>
+        </p:nvSpPr>
+        <p:spPr>
+          <a:xfrm>
+            <a:off x="457200" y="381000"/>
+            <a:ext cx="11277600" cy="1143000"/>
+          </a:xfrm>
+          <a:prstGeom prst="rect">
+            <a:avLst/>
+          </a:prstGeom>
+        </p:spPr>
+        <p:txBody>
+          <a:bodyPr anchor="t" wrap="square">
+            <a:normAutofit/>
+          </a:bodyPr>
+          <a:lstStyle/>
+          <a:p>
+            <a:pPr>
+              <a:buNone/>
+            </a:pPr>
+            <a:r>
+              <a:rPr lang="zh-HK" sz="3600" b="1">
+                <a:solidFill>
+                  <a:srgbClr val="F97316"/>
+                </a:solidFill>
+              </a:rPr>
+              <a:t>出 dispute 嗰陣,你唔需要靠記性</a:t>
+            </a:r>
+          </a:p>
+        </p:txBody>
+      </p:sp>
+      <p:sp>
+        <p:nvSpPr>
+          <p:cNvPr id="4" name="Body"/>
+          <p:cNvSpPr>
+            <a:spLocks noGrp="1"/>
+          </p:cNvSpPr>
+          <p:nvPr>
+            <p:ph type="body" idx="1"/>
+          </p:nvPr>
+        </p:nvSpPr>
+        <p:spPr>
+          <a:xfrm>
+            <a:off x="457200" y="1619250"/>
+            <a:ext cx="11277600" cy="4857750"/>
+          </a:xfrm>
+          <a:prstGeom prst="rect">
+            <a:avLst/>
+          </a:prstGeom>
+        </p:spPr>
+        <p:txBody>
+          <a:bodyPr anchor="t" wrap="square">
+            <a:normAutofit/>
+          </a:bodyPr>
+          <a:lstStyle/>
+          <a:p>
+            <a:pPr>
+              <a:buNone/>
+            </a:pPr>
+            <a:r>
+              <a:rPr lang="zh-HK" sz="1600" b="1">
+                <a:solidFill>
+                  <a:srgbClr val="F97316"/>
+                </a:solidFill>
+              </a:rPr>
+              <a:t>一個系統,一條完整審計軌跡</a:t>
+            </a:r>
+          </a:p>
+          <a:p>
+            <a:pPr>
+              <a:buNone/>
+            </a:pPr>
+            <a:endParaRPr lang="zh-HK" sz="600"/>
+          </a:p>
+          <a:p>
+            <a:pPr marL="285750" indent="-285750">
+              <a:buFont typeface="Arial"/>
+              <a:buChar char="•"/>
+            </a:pPr>
+            <a:r>
+              <a:rPr lang="zh-HK" sz="1400">
+                <a:solidFill>
+                  <a:srgbClr val="E2E8F0"/>
+                </a:solidFill>
+              </a:rPr>
+              <a:t>判頭 + 工地主任永遠知道每個地盤發生緊乜事</a:t>
+            </a:r>
+          </a:p>
+          <a:p>
+            <a:pPr marL="285750" indent="-285750">
+              <a:buFont typeface="Arial"/>
+              <a:buChar char="•"/>
+            </a:pPr>
+            <a:r>
+              <a:rPr lang="zh-HK" sz="1400">
+                <a:solidFill>
+                  <a:srgbClr val="E2E8F0"/>
+                </a:solidFill>
+              </a:rPr>
+              <a:t>每一個指令、許可證、圖則、進度、問題都記低,改唔走、刪唔到</a:t>
+            </a:r>
+          </a:p>
+          <a:p>
+            <a:pPr marL="285750" indent="-285750">
+              <a:buFont typeface="Arial"/>
+              <a:buChar char="•"/>
+            </a:pPr>
+            <a:r>
+              <a:rPr lang="zh-HK" sz="1400">
+                <a:solidFill>
+                  <a:srgbClr val="E2E8F0"/>
+                </a:solidFill>
+              </a:rPr>
+              <a:t>iOS App Store 已上架 · Android 測試中 · 即開 Web 版</a:t>
+            </a:r>
+          </a:p>
+          <a:p>
+            <a:pPr marL="285750" indent="-285750">
+              <a:buFont typeface="Arial"/>
+              <a:buChar char="•"/>
+            </a:pPr>
+            <a:r>
+              <a:rPr lang="zh-HK" sz="1400">
+                <a:solidFill>
+                  <a:srgbClr val="E2E8F0"/>
+                </a:solidFill>
+              </a:rPr>
+              <a:t>想試?想 demo?想直接傾價? —— 揀一個,我哋當日搵你</a:t>
+            </a:r>
+          </a:p>
+          <a:p>
+            <a:pPr>
+              <a:buNone/>
+            </a:pPr>
+            <a:endParaRPr lang="zh-HK" sz="600"/>
+          </a:p>
+          <a:p>
+            <a:pPr>
+              <a:buNone/>
+            </a:pPr>
+            <a:r>
+              <a:rPr lang="zh-HK" sz="1000" i="1">
+                <a:solidFill>
+                  <a:srgbClr val="94A3B8"/>
+                </a:solidFill>
+              </a:rPr>
+              <a:t>講者備註 · 收尾 CTA。回扣開場 thesis(永遠知道 + 審計軌跡)。三個渠道(App Store / Web / demo)。語氣輕鬆收結,留低聯絡。</a:t>
             </a:r>
           </a:p>
         </p:txBody>

</xml_diff>